<commit_message>
docs(review3): deck gains architecture, algorithm, growth-model and roadmap slides
</commit_message>
<xml_diff>
--- a/docs/Review3_Presentation.pptx
+++ b/docs/Review3_Presentation.pptx
@@ -18,6 +18,10 @@
     <p:sldId id="266" r:id="rId17"/>
     <p:sldId id="267" r:id="rId18"/>
     <p:sldId id="268" r:id="rId19"/>
+    <p:sldId id="269" r:id="rId20"/>
+    <p:sldId id="270" r:id="rId21"/>
+    <p:sldId id="271" r:id="rId22"/>
+    <p:sldId id="272" r:id="rId23"/>
   </p:sldIdLst>
   <p:sldSz cx="12191695" cy="6858000" type="screen4x3"/>
   <p:notesSz cx="6858000" cy="9144000"/>
@@ -3339,6 +3343,1144 @@
 </file>
 
 <file path=ppt/slides/slide10.xml><?xml version="1.0" encoding="utf-8"?>
+<p:sld xmlns:a="http://schemas.openxmlformats.org/drawingml/2006/main" xmlns:p="http://schemas.openxmlformats.org/presentationml/2006/main" xmlns:r="http://schemas.openxmlformats.org/officeDocument/2006/relationships">
+  <p:cSld>
+    <p:spTree>
+      <p:nvGrpSpPr>
+        <p:cNvPr id="1" name=""/>
+        <p:cNvGrpSpPr/>
+        <p:nvPr/>
+      </p:nvGrpSpPr>
+      <p:grpSpPr/>
+      <p:sp>
+        <p:nvSpPr>
+          <p:cNvPr id="2" name="Rectangle 1"/>
+          <p:cNvSpPr/>
+          <p:nvPr/>
+        </p:nvSpPr>
+        <p:spPr>
+          <a:xfrm>
+            <a:off x="0" y="0"/>
+            <a:ext cx="12191695" cy="6858000"/>
+          </a:xfrm>
+          <a:prstGeom prst="rect">
+            <a:avLst/>
+          </a:prstGeom>
+          <a:solidFill>
+            <a:srgbClr val="FFFFFF"/>
+          </a:solidFill>
+          <a:ln>
+            <a:noFill/>
+          </a:ln>
+          <a:effectLst/>
+        </p:spPr>
+        <p:style>
+          <a:lnRef idx="1">
+            <a:schemeClr val="accent1"/>
+          </a:lnRef>
+          <a:fillRef idx="3">
+            <a:schemeClr val="accent1"/>
+          </a:fillRef>
+          <a:effectRef idx="2">
+            <a:schemeClr val="accent1"/>
+          </a:effectRef>
+          <a:fontRef idx="minor">
+            <a:schemeClr val="lt1"/>
+          </a:fontRef>
+        </p:style>
+        <p:txBody>
+          <a:bodyPr rtlCol="0" anchor="ctr"/>
+          <a:lstStyle/>
+          <a:p>
+            <a:pPr algn="ctr"/>
+          </a:p>
+        </p:txBody>
+      </p:sp>
+      <p:sp>
+        <p:nvSpPr>
+          <p:cNvPr id="3" name="TextBox 2"/>
+          <p:cNvSpPr txBox="1"/>
+          <p:nvPr/>
+        </p:nvSpPr>
+        <p:spPr>
+          <a:xfrm>
+            <a:off x="640080" y="384048"/>
+            <a:ext cx="10972800" cy="822960"/>
+          </a:xfrm>
+          <a:prstGeom prst="rect">
+            <a:avLst/>
+          </a:prstGeom>
+          <a:noFill/>
+        </p:spPr>
+        <p:txBody>
+          <a:bodyPr wrap="square">
+            <a:spAutoFit/>
+          </a:bodyPr>
+          <a:lstStyle/>
+          <a:p>
+            <a:pPr algn="l">
+              <a:spcAft>
+                <a:spcPts val="200"/>
+              </a:spcAft>
+            </a:pPr>
+            <a:r>
+              <a:rPr sz="3000" b="1">
+                <a:solidFill>
+                  <a:srgbClr val="101826"/>
+                </a:solidFill>
+                <a:latin typeface="Segoe UI"/>
+              </a:rPr>
+              <a:t>What a flagged zone actually looks like</a:t>
+            </a:r>
+          </a:p>
+          <a:p>
+            <a:pPr>
+              <a:spcAft>
+                <a:spcPts val="0"/>
+              </a:spcAft>
+            </a:pPr>
+            <a:r>
+              <a:rPr sz="1350" b="0">
+                <a:solidFill>
+                  <a:srgbClr val="1B5FAF"/>
+                </a:solidFill>
+                <a:latin typeface="Segoe UI"/>
+              </a:rPr>
+              <a:t>One evidence card of 23</a:t>
+            </a:r>
+          </a:p>
+        </p:txBody>
+      </p:sp>
+      <p:sp>
+        <p:nvSpPr>
+          <p:cNvPr id="4" name="Rectangle 3"/>
+          <p:cNvSpPr/>
+          <p:nvPr/>
+        </p:nvSpPr>
+        <p:spPr>
+          <a:xfrm>
+            <a:off x="640080" y="1298448"/>
+            <a:ext cx="1371600" cy="38100"/>
+          </a:xfrm>
+          <a:prstGeom prst="rect">
+            <a:avLst/>
+          </a:prstGeom>
+          <a:solidFill>
+            <a:srgbClr val="1B5FAF"/>
+          </a:solidFill>
+          <a:ln>
+            <a:noFill/>
+          </a:ln>
+          <a:effectLst/>
+        </p:spPr>
+        <p:style>
+          <a:lnRef idx="1">
+            <a:schemeClr val="accent1"/>
+          </a:lnRef>
+          <a:fillRef idx="3">
+            <a:schemeClr val="accent1"/>
+          </a:fillRef>
+          <a:effectRef idx="2">
+            <a:schemeClr val="accent1"/>
+          </a:effectRef>
+          <a:fontRef idx="minor">
+            <a:schemeClr val="lt1"/>
+          </a:fontRef>
+        </p:style>
+        <p:txBody>
+          <a:bodyPr rtlCol="0" anchor="ctr"/>
+          <a:lstStyle/>
+          <a:p>
+            <a:pPr algn="ctr"/>
+          </a:p>
+        </p:txBody>
+      </p:sp>
+      <p:pic>
+        <p:nvPicPr>
+          <p:cNvPr id="5" name="Picture 4" descr="zone_01.png"/>
+          <p:cNvPicPr>
+            <a:picLocks noChangeAspect="1"/>
+          </p:cNvPicPr>
+          <p:nvPr/>
+        </p:nvPicPr>
+        <p:blipFill>
+          <a:blip r:embed="rId2"/>
+          <a:stretch>
+            <a:fillRect/>
+          </a:stretch>
+        </p:blipFill>
+        <p:spPr>
+          <a:xfrm>
+            <a:off x="640080" y="1600200"/>
+            <a:ext cx="7772400" cy="4902591"/>
+          </a:xfrm>
+          <a:prstGeom prst="rect">
+            <a:avLst/>
+          </a:prstGeom>
+        </p:spPr>
+      </p:pic>
+      <p:sp>
+        <p:nvSpPr>
+          <p:cNvPr id="6" name="Rectangle 5"/>
+          <p:cNvSpPr/>
+          <p:nvPr/>
+        </p:nvSpPr>
+        <p:spPr>
+          <a:xfrm>
+            <a:off x="8686800" y="1737360"/>
+            <a:ext cx="2834640" cy="960120"/>
+          </a:xfrm>
+          <a:prstGeom prst="rect">
+            <a:avLst/>
+          </a:prstGeom>
+          <a:solidFill>
+            <a:srgbClr val="F1F5FA"/>
+          </a:solidFill>
+          <a:ln w="9525">
+            <a:solidFill>
+              <a:srgbClr val="C3CEDC"/>
+            </a:solidFill>
+          </a:ln>
+          <a:effectLst/>
+        </p:spPr>
+        <p:style>
+          <a:lnRef idx="1">
+            <a:schemeClr val="accent1"/>
+          </a:lnRef>
+          <a:fillRef idx="3">
+            <a:schemeClr val="accent1"/>
+          </a:fillRef>
+          <a:effectRef idx="2">
+            <a:schemeClr val="accent1"/>
+          </a:effectRef>
+          <a:fontRef idx="minor">
+            <a:schemeClr val="lt1"/>
+          </a:fontRef>
+        </p:style>
+        <p:txBody>
+          <a:bodyPr rtlCol="0" anchor="ctr"/>
+          <a:lstStyle/>
+          <a:p>
+            <a:pPr algn="ctr"/>
+          </a:p>
+        </p:txBody>
+      </p:sp>
+      <p:sp>
+        <p:nvSpPr>
+          <p:cNvPr id="7" name="TextBox 6"/>
+          <p:cNvSpPr txBox="1"/>
+          <p:nvPr/>
+        </p:nvSpPr>
+        <p:spPr>
+          <a:xfrm>
+            <a:off x="8814816" y="1828800"/>
+            <a:ext cx="2578608" cy="777240"/>
+          </a:xfrm>
+          <a:prstGeom prst="rect">
+            <a:avLst/>
+          </a:prstGeom>
+          <a:noFill/>
+        </p:spPr>
+        <p:txBody>
+          <a:bodyPr wrap="square">
+            <a:spAutoFit/>
+          </a:bodyPr>
+          <a:lstStyle/>
+          <a:p>
+            <a:pPr algn="l">
+              <a:spcAft>
+                <a:spcPts val="200"/>
+              </a:spcAft>
+            </a:pPr>
+            <a:r>
+              <a:rPr sz="2000" b="1">
+                <a:solidFill>
+                  <a:srgbClr val="1B5FAF"/>
+                </a:solidFill>
+                <a:latin typeface="Segoe UI"/>
+              </a:rPr>
+              <a:t>23</a:t>
+            </a:r>
+          </a:p>
+          <a:p>
+            <a:pPr>
+              <a:spcAft>
+                <a:spcPts val="0"/>
+              </a:spcAft>
+            </a:pPr>
+            <a:r>
+              <a:rPr sz="1050" b="0">
+                <a:solidFill>
+                  <a:srgbClr val="5A6474"/>
+                </a:solidFill>
+                <a:latin typeface="Segoe UI"/>
+              </a:rPr>
+              <a:t>zones flagged, all peripheral</a:t>
+            </a:r>
+          </a:p>
+        </p:txBody>
+      </p:sp>
+      <p:sp>
+        <p:nvSpPr>
+          <p:cNvPr id="8" name="Rectangle 7"/>
+          <p:cNvSpPr/>
+          <p:nvPr/>
+        </p:nvSpPr>
+        <p:spPr>
+          <a:xfrm>
+            <a:off x="8686800" y="2834640"/>
+            <a:ext cx="2834640" cy="960120"/>
+          </a:xfrm>
+          <a:prstGeom prst="rect">
+            <a:avLst/>
+          </a:prstGeom>
+          <a:solidFill>
+            <a:srgbClr val="F1F5FA"/>
+          </a:solidFill>
+          <a:ln w="9525">
+            <a:solidFill>
+              <a:srgbClr val="C3CEDC"/>
+            </a:solidFill>
+          </a:ln>
+          <a:effectLst/>
+        </p:spPr>
+        <p:style>
+          <a:lnRef idx="1">
+            <a:schemeClr val="accent1"/>
+          </a:lnRef>
+          <a:fillRef idx="3">
+            <a:schemeClr val="accent1"/>
+          </a:fillRef>
+          <a:effectRef idx="2">
+            <a:schemeClr val="accent1"/>
+          </a:effectRef>
+          <a:fontRef idx="minor">
+            <a:schemeClr val="lt1"/>
+          </a:fontRef>
+        </p:style>
+        <p:txBody>
+          <a:bodyPr rtlCol="0" anchor="ctr"/>
+          <a:lstStyle/>
+          <a:p>
+            <a:pPr algn="ctr"/>
+          </a:p>
+        </p:txBody>
+      </p:sp>
+      <p:sp>
+        <p:nvSpPr>
+          <p:cNvPr id="9" name="TextBox 8"/>
+          <p:cNvSpPr txBox="1"/>
+          <p:nvPr/>
+        </p:nvSpPr>
+        <p:spPr>
+          <a:xfrm>
+            <a:off x="8814816" y="2926080"/>
+            <a:ext cx="2578608" cy="777240"/>
+          </a:xfrm>
+          <a:prstGeom prst="rect">
+            <a:avLst/>
+          </a:prstGeom>
+          <a:noFill/>
+        </p:spPr>
+        <p:txBody>
+          <a:bodyPr wrap="square">
+            <a:spAutoFit/>
+          </a:bodyPr>
+          <a:lstStyle/>
+          <a:p>
+            <a:pPr algn="l">
+              <a:spcAft>
+                <a:spcPts val="200"/>
+              </a:spcAft>
+            </a:pPr>
+            <a:r>
+              <a:rPr sz="2000" b="1">
+                <a:solidFill>
+                  <a:srgbClr val="0E7A52"/>
+                </a:solidFill>
+                <a:latin typeface="Segoe UI"/>
+              </a:rPr>
+              <a:t>82 %</a:t>
+            </a:r>
+          </a:p>
+          <a:p>
+            <a:pPr>
+              <a:spcAft>
+                <a:spcPts val="0"/>
+              </a:spcAft>
+            </a:pPr>
+            <a:r>
+              <a:rPr sz="1050" b="0">
+                <a:solidFill>
+                  <a:srgbClr val="5A6474"/>
+                </a:solidFill>
+                <a:latin typeface="Segoe UI"/>
+              </a:rPr>
+              <a:t>of ghost cells contain buildings in 2023 (Open Buildings)</a:t>
+            </a:r>
+          </a:p>
+        </p:txBody>
+      </p:sp>
+      <p:sp>
+        <p:nvSpPr>
+          <p:cNvPr id="10" name="Rectangle 9"/>
+          <p:cNvSpPr/>
+          <p:nvPr/>
+        </p:nvSpPr>
+        <p:spPr>
+          <a:xfrm>
+            <a:off x="8686800" y="3931920"/>
+            <a:ext cx="2834640" cy="960120"/>
+          </a:xfrm>
+          <a:prstGeom prst="rect">
+            <a:avLst/>
+          </a:prstGeom>
+          <a:solidFill>
+            <a:srgbClr val="F1F5FA"/>
+          </a:solidFill>
+          <a:ln w="9525">
+            <a:solidFill>
+              <a:srgbClr val="C3CEDC"/>
+            </a:solidFill>
+          </a:ln>
+          <a:effectLst/>
+        </p:spPr>
+        <p:style>
+          <a:lnRef idx="1">
+            <a:schemeClr val="accent1"/>
+          </a:lnRef>
+          <a:fillRef idx="3">
+            <a:schemeClr val="accent1"/>
+          </a:fillRef>
+          <a:effectRef idx="2">
+            <a:schemeClr val="accent1"/>
+          </a:effectRef>
+          <a:fontRef idx="minor">
+            <a:schemeClr val="lt1"/>
+          </a:fontRef>
+        </p:style>
+        <p:txBody>
+          <a:bodyPr rtlCol="0" anchor="ctr"/>
+          <a:lstStyle/>
+          <a:p>
+            <a:pPr algn="ctr"/>
+          </a:p>
+        </p:txBody>
+      </p:sp>
+      <p:sp>
+        <p:nvSpPr>
+          <p:cNvPr id="11" name="TextBox 10"/>
+          <p:cNvSpPr txBox="1"/>
+          <p:nvPr/>
+        </p:nvSpPr>
+        <p:spPr>
+          <a:xfrm>
+            <a:off x="8814816" y="4023360"/>
+            <a:ext cx="2578608" cy="777240"/>
+          </a:xfrm>
+          <a:prstGeom prst="rect">
+            <a:avLst/>
+          </a:prstGeom>
+          <a:noFill/>
+        </p:spPr>
+        <p:txBody>
+          <a:bodyPr wrap="square">
+            <a:spAutoFit/>
+          </a:bodyPr>
+          <a:lstStyle/>
+          <a:p>
+            <a:pPr algn="l">
+              <a:spcAft>
+                <a:spcPts val="200"/>
+              </a:spcAft>
+            </a:pPr>
+            <a:r>
+              <a:rPr sz="2000" b="1">
+                <a:solidFill>
+                  <a:srgbClr val="B26A00"/>
+                </a:solidFill>
+                <a:latin typeface="Segoe UI"/>
+              </a:rPr>
+              <a:t>26 of 144</a:t>
+            </a:r>
+          </a:p>
+          <a:p>
+            <a:pPr>
+              <a:spcAft>
+                <a:spcPts val="0"/>
+              </a:spcAft>
+            </a:pPr>
+            <a:r>
+              <a:rPr sz="1050" b="0">
+                <a:solidFill>
+                  <a:srgbClr val="5A6474"/>
+                </a:solidFill>
+                <a:latin typeface="Segoe UI"/>
+              </a:rPr>
+              <a:t>ghost cells have no buildings - likely GHSL false positives</a:t>
+            </a:r>
+          </a:p>
+        </p:txBody>
+      </p:sp>
+      <p:sp>
+        <p:nvSpPr>
+          <p:cNvPr id="12" name="Rectangle 11"/>
+          <p:cNvSpPr/>
+          <p:nvPr/>
+        </p:nvSpPr>
+        <p:spPr>
+          <a:xfrm>
+            <a:off x="8686800" y="5029200"/>
+            <a:ext cx="2834640" cy="960120"/>
+          </a:xfrm>
+          <a:prstGeom prst="rect">
+            <a:avLst/>
+          </a:prstGeom>
+          <a:solidFill>
+            <a:srgbClr val="F1F5FA"/>
+          </a:solidFill>
+          <a:ln w="9525">
+            <a:solidFill>
+              <a:srgbClr val="C3CEDC"/>
+            </a:solidFill>
+          </a:ln>
+          <a:effectLst/>
+        </p:spPr>
+        <p:style>
+          <a:lnRef idx="1">
+            <a:schemeClr val="accent1"/>
+          </a:lnRef>
+          <a:fillRef idx="3">
+            <a:schemeClr val="accent1"/>
+          </a:fillRef>
+          <a:effectRef idx="2">
+            <a:schemeClr val="accent1"/>
+          </a:effectRef>
+          <a:fontRef idx="minor">
+            <a:schemeClr val="lt1"/>
+          </a:fontRef>
+        </p:style>
+        <p:txBody>
+          <a:bodyPr rtlCol="0" anchor="ctr"/>
+          <a:lstStyle/>
+          <a:p>
+            <a:pPr algn="ctr"/>
+          </a:p>
+        </p:txBody>
+      </p:sp>
+      <p:sp>
+        <p:nvSpPr>
+          <p:cNvPr id="13" name="TextBox 12"/>
+          <p:cNvSpPr txBox="1"/>
+          <p:nvPr/>
+        </p:nvSpPr>
+        <p:spPr>
+          <a:xfrm>
+            <a:off x="8814816" y="5120640"/>
+            <a:ext cx="2578608" cy="777240"/>
+          </a:xfrm>
+          <a:prstGeom prst="rect">
+            <a:avLst/>
+          </a:prstGeom>
+          <a:noFill/>
+        </p:spPr>
+        <p:txBody>
+          <a:bodyPr wrap="square">
+            <a:spAutoFit/>
+          </a:bodyPr>
+          <a:lstStyle/>
+          <a:p>
+            <a:pPr algn="l">
+              <a:spcAft>
+                <a:spcPts val="200"/>
+              </a:spcAft>
+            </a:pPr>
+            <a:r>
+              <a:rPr sz="2000" b="1">
+                <a:solidFill>
+                  <a:srgbClr val="1B5FAF"/>
+                </a:solidFill>
+                <a:latin typeface="Segoe UI"/>
+              </a:rPr>
+              <a:t>+0.32 m</a:t>
+            </a:r>
+          </a:p>
+          <a:p>
+            <a:pPr>
+              <a:spcAft>
+                <a:spcPts val="0"/>
+              </a:spcAft>
+            </a:pPr>
+            <a:r>
+              <a:rPr sz="1050" b="0">
+                <a:solidFill>
+                  <a:srgbClr val="5A6474"/>
+                </a:solidFill>
+                <a:latin typeface="Segoe UI"/>
+              </a:rPr>
+              <a:t>building height gained 2016-2023 in ghost cells</a:t>
+            </a:r>
+          </a:p>
+        </p:txBody>
+      </p:sp>
+      <p:sp>
+        <p:nvSpPr>
+          <p:cNvPr id="14" name="TextBox 13"/>
+          <p:cNvSpPr txBox="1"/>
+          <p:nvPr/>
+        </p:nvSpPr>
+        <p:spPr>
+          <a:xfrm>
+            <a:off x="640080" y="6291072"/>
+            <a:ext cx="10972800" cy="274320"/>
+          </a:xfrm>
+          <a:prstGeom prst="rect">
+            <a:avLst/>
+          </a:prstGeom>
+          <a:noFill/>
+        </p:spPr>
+        <p:txBody>
+          <a:bodyPr wrap="square">
+            <a:spAutoFit/>
+          </a:bodyPr>
+          <a:lstStyle/>
+          <a:p>
+            <a:pPr algn="l">
+              <a:spcAft>
+                <a:spcPts val="0"/>
+              </a:spcAft>
+            </a:pPr>
+            <a:r>
+              <a:rPr sz="950" b="0">
+                <a:solidFill>
+                  <a:srgbClr val="5A6474"/>
+                </a:solidFill>
+                <a:latin typeface="Segoe UI"/>
+              </a:rPr>
+              <a:t>Evidence for a reader, not a validation: precision stays unmeasured until ground or image labels exist - Review 4.</a:t>
+            </a:r>
+          </a:p>
+        </p:txBody>
+      </p:sp>
+    </p:spTree>
+  </p:cSld>
+  <p:clrMapOvr>
+    <a:masterClrMapping/>
+  </p:clrMapOvr>
+</p:sld>
+</file>
+
+<file path=ppt/slides/slide11.xml><?xml version="1.0" encoding="utf-8"?>
+<p:sld xmlns:a="http://schemas.openxmlformats.org/drawingml/2006/main" xmlns:p="http://schemas.openxmlformats.org/presentationml/2006/main" xmlns:r="http://schemas.openxmlformats.org/officeDocument/2006/relationships">
+  <p:cSld>
+    <p:spTree>
+      <p:nvGrpSpPr>
+        <p:cNvPr id="1" name=""/>
+        <p:cNvGrpSpPr/>
+        <p:nvPr/>
+      </p:nvGrpSpPr>
+      <p:grpSpPr/>
+      <p:sp>
+        <p:nvSpPr>
+          <p:cNvPr id="2" name="Rectangle 1"/>
+          <p:cNvSpPr/>
+          <p:nvPr/>
+        </p:nvSpPr>
+        <p:spPr>
+          <a:xfrm>
+            <a:off x="0" y="0"/>
+            <a:ext cx="12191695" cy="6858000"/>
+          </a:xfrm>
+          <a:prstGeom prst="rect">
+            <a:avLst/>
+          </a:prstGeom>
+          <a:solidFill>
+            <a:srgbClr val="FFFFFF"/>
+          </a:solidFill>
+          <a:ln>
+            <a:noFill/>
+          </a:ln>
+          <a:effectLst/>
+        </p:spPr>
+        <p:style>
+          <a:lnRef idx="1">
+            <a:schemeClr val="accent1"/>
+          </a:lnRef>
+          <a:fillRef idx="3">
+            <a:schemeClr val="accent1"/>
+          </a:fillRef>
+          <a:effectRef idx="2">
+            <a:schemeClr val="accent1"/>
+          </a:effectRef>
+          <a:fontRef idx="minor">
+            <a:schemeClr val="lt1"/>
+          </a:fontRef>
+        </p:style>
+        <p:txBody>
+          <a:bodyPr rtlCol="0" anchor="ctr"/>
+          <a:lstStyle/>
+          <a:p>
+            <a:pPr algn="ctr"/>
+          </a:p>
+        </p:txBody>
+      </p:sp>
+      <p:sp>
+        <p:nvSpPr>
+          <p:cNvPr id="3" name="TextBox 2"/>
+          <p:cNvSpPr txBox="1"/>
+          <p:nvPr/>
+        </p:nvSpPr>
+        <p:spPr>
+          <a:xfrm>
+            <a:off x="640080" y="384048"/>
+            <a:ext cx="10972800" cy="822960"/>
+          </a:xfrm>
+          <a:prstGeom prst="rect">
+            <a:avLst/>
+          </a:prstGeom>
+          <a:noFill/>
+        </p:spPr>
+        <p:txBody>
+          <a:bodyPr wrap="square">
+            <a:spAutoFit/>
+          </a:bodyPr>
+          <a:lstStyle/>
+          <a:p>
+            <a:pPr algn="l">
+              <a:spcAft>
+                <a:spcPts val="200"/>
+              </a:spcAft>
+            </a:pPr>
+            <a:r>
+              <a:rPr sz="3000" b="1">
+                <a:solidFill>
+                  <a:srgbClr val="101826"/>
+                </a:solidFill>
+                <a:latin typeface="Segoe UI"/>
+              </a:rPr>
+              <a:t>Surface heat: the result reversed</a:t>
+            </a:r>
+          </a:p>
+          <a:p>
+            <a:pPr>
+              <a:spcAft>
+                <a:spcPts val="0"/>
+              </a:spcAft>
+            </a:pPr>
+            <a:r>
+              <a:rPr sz="1350" b="0">
+                <a:solidFill>
+                  <a:srgbClr val="1B5FAF"/>
+                </a:solidFill>
+                <a:latin typeface="Segoe UI"/>
+              </a:rPr>
+              <a:t>March to May, daytime</a:t>
+            </a:r>
+          </a:p>
+        </p:txBody>
+      </p:sp>
+      <p:sp>
+        <p:nvSpPr>
+          <p:cNvPr id="4" name="Rectangle 3"/>
+          <p:cNvSpPr/>
+          <p:nvPr/>
+        </p:nvSpPr>
+        <p:spPr>
+          <a:xfrm>
+            <a:off x="640080" y="1298448"/>
+            <a:ext cx="1371600" cy="38100"/>
+          </a:xfrm>
+          <a:prstGeom prst="rect">
+            <a:avLst/>
+          </a:prstGeom>
+          <a:solidFill>
+            <a:srgbClr val="1B5FAF"/>
+          </a:solidFill>
+          <a:ln>
+            <a:noFill/>
+          </a:ln>
+          <a:effectLst/>
+        </p:spPr>
+        <p:style>
+          <a:lnRef idx="1">
+            <a:schemeClr val="accent1"/>
+          </a:lnRef>
+          <a:fillRef idx="3">
+            <a:schemeClr val="accent1"/>
+          </a:fillRef>
+          <a:effectRef idx="2">
+            <a:schemeClr val="accent1"/>
+          </a:effectRef>
+          <a:fontRef idx="minor">
+            <a:schemeClr val="lt1"/>
+          </a:fontRef>
+        </p:style>
+        <p:txBody>
+          <a:bodyPr rtlCol="0" anchor="ctr"/>
+          <a:lstStyle/>
+          <a:p>
+            <a:pPr algn="ctr"/>
+          </a:p>
+        </p:txBody>
+      </p:sp>
+      <p:pic>
+        <p:nvPicPr>
+          <p:cNvPr id="5" name="Picture 4" descr="F12_land_surface_temperature.png"/>
+          <p:cNvPicPr>
+            <a:picLocks noChangeAspect="1"/>
+          </p:cNvPicPr>
+          <p:nvPr/>
+        </p:nvPicPr>
+        <p:blipFill>
+          <a:blip r:embed="rId2"/>
+          <a:stretch>
+            <a:fillRect/>
+          </a:stretch>
+        </p:blipFill>
+        <p:spPr>
+          <a:xfrm>
+            <a:off x="640080" y="1600200"/>
+            <a:ext cx="10881360" cy="3570256"/>
+          </a:xfrm>
+          <a:prstGeom prst="rect">
+            <a:avLst/>
+          </a:prstGeom>
+        </p:spPr>
+      </p:pic>
+      <p:sp>
+        <p:nvSpPr>
+          <p:cNvPr id="6" name="Rectangle 5"/>
+          <p:cNvSpPr/>
+          <p:nvPr/>
+        </p:nvSpPr>
+        <p:spPr>
+          <a:xfrm>
+            <a:off x="640080" y="4709160"/>
+            <a:ext cx="10881360" cy="1463040"/>
+          </a:xfrm>
+          <a:prstGeom prst="rect">
+            <a:avLst/>
+          </a:prstGeom>
+          <a:solidFill>
+            <a:srgbClr val="F1F5FA"/>
+          </a:solidFill>
+          <a:ln w="9525">
+            <a:solidFill>
+              <a:srgbClr val="B26A00"/>
+            </a:solidFill>
+          </a:ln>
+          <a:effectLst/>
+        </p:spPr>
+        <p:style>
+          <a:lnRef idx="1">
+            <a:schemeClr val="accent1"/>
+          </a:lnRef>
+          <a:fillRef idx="3">
+            <a:schemeClr val="accent1"/>
+          </a:fillRef>
+          <a:effectRef idx="2">
+            <a:schemeClr val="accent1"/>
+          </a:effectRef>
+          <a:fontRef idx="minor">
+            <a:schemeClr val="lt1"/>
+          </a:fontRef>
+        </p:style>
+        <p:txBody>
+          <a:bodyPr rtlCol="0" anchor="ctr"/>
+          <a:lstStyle/>
+          <a:p>
+            <a:pPr algn="ctr"/>
+          </a:p>
+        </p:txBody>
+      </p:sp>
+      <p:sp>
+        <p:nvSpPr>
+          <p:cNvPr id="7" name="TextBox 6"/>
+          <p:cNvSpPr txBox="1"/>
+          <p:nvPr/>
+        </p:nvSpPr>
+        <p:spPr>
+          <a:xfrm>
+            <a:off x="868680" y="4846320"/>
+            <a:ext cx="10424160" cy="1234440"/>
+          </a:xfrm>
+          <a:prstGeom prst="rect">
+            <a:avLst/>
+          </a:prstGeom>
+          <a:noFill/>
+        </p:spPr>
+        <p:txBody>
+          <a:bodyPr wrap="square">
+            <a:spAutoFit/>
+          </a:bodyPr>
+          <a:lstStyle/>
+          <a:p>
+            <a:pPr algn="l">
+              <a:spcAft>
+                <a:spcPts val="400"/>
+              </a:spcAft>
+            </a:pPr>
+            <a:r>
+              <a:rPr sz="1500" b="1">
+                <a:solidFill>
+                  <a:srgbClr val="B26A00"/>
+                </a:solidFill>
+                <a:latin typeface="Segoe UI"/>
+              </a:rPr>
+              <a:t>Varanasi has no daytime surface heat island in the pre-monsoon season.</a:t>
+            </a:r>
+          </a:p>
+          <a:p>
+            <a:pPr>
+              <a:spcAft>
+                <a:spcPts val="0"/>
+              </a:spcAft>
+            </a:pPr>
+            <a:r>
+              <a:rPr sz="1250" b="0">
+                <a:solidFill>
+                  <a:srgbClr val="5A6474"/>
+                </a:solidFill>
+                <a:latin typeface="Segoe UI"/>
+              </a:rPr>
+              <a:t>Measured over urban cells, the built-up area is 1.66 C cooler than the dry, bare farmland around it, and MODIS - an independent sensor - shows no heat island either. 22.3 of the 23.8 km2 of hotspots lie on rural land. Review 2's +1.10 C was the mean over only the cells warmer than rural, which is positive by construction. Heat vulnerability, which weights heat by residents, remains the planning layer.</a:t>
+            </a:r>
+          </a:p>
+        </p:txBody>
+      </p:sp>
+    </p:spTree>
+  </p:cSld>
+  <p:clrMapOvr>
+    <a:masterClrMapping/>
+  </p:clrMapOvr>
+</p:sld>
+</file>
+
+<file path=ppt/slides/slide12.xml><?xml version="1.0" encoding="utf-8"?>
+<p:sld xmlns:a="http://schemas.openxmlformats.org/drawingml/2006/main" xmlns:p="http://schemas.openxmlformats.org/presentationml/2006/main" xmlns:r="http://schemas.openxmlformats.org/officeDocument/2006/relationships">
+  <p:cSld>
+    <p:spTree>
+      <p:nvGrpSpPr>
+        <p:cNvPr id="1" name=""/>
+        <p:cNvGrpSpPr/>
+        <p:nvPr/>
+      </p:nvGrpSpPr>
+      <p:grpSpPr/>
+      <p:sp>
+        <p:nvSpPr>
+          <p:cNvPr id="2" name="Rectangle 1"/>
+          <p:cNvSpPr/>
+          <p:nvPr/>
+        </p:nvSpPr>
+        <p:spPr>
+          <a:xfrm>
+            <a:off x="0" y="0"/>
+            <a:ext cx="12191695" cy="6858000"/>
+          </a:xfrm>
+          <a:prstGeom prst="rect">
+            <a:avLst/>
+          </a:prstGeom>
+          <a:solidFill>
+            <a:srgbClr val="FFFFFF"/>
+          </a:solidFill>
+          <a:ln>
+            <a:noFill/>
+          </a:ln>
+          <a:effectLst/>
+        </p:spPr>
+        <p:style>
+          <a:lnRef idx="1">
+            <a:schemeClr val="accent1"/>
+          </a:lnRef>
+          <a:fillRef idx="3">
+            <a:schemeClr val="accent1"/>
+          </a:fillRef>
+          <a:effectRef idx="2">
+            <a:schemeClr val="accent1"/>
+          </a:effectRef>
+          <a:fontRef idx="minor">
+            <a:schemeClr val="lt1"/>
+          </a:fontRef>
+        </p:style>
+        <p:txBody>
+          <a:bodyPr rtlCol="0" anchor="ctr"/>
+          <a:lstStyle/>
+          <a:p>
+            <a:pPr algn="ctr"/>
+          </a:p>
+        </p:txBody>
+      </p:sp>
+      <p:sp>
+        <p:nvSpPr>
+          <p:cNvPr id="3" name="TextBox 2"/>
+          <p:cNvSpPr txBox="1"/>
+          <p:nvPr/>
+        </p:nvSpPr>
+        <p:spPr>
+          <a:xfrm>
+            <a:off x="640080" y="384048"/>
+            <a:ext cx="10972800" cy="822960"/>
+          </a:xfrm>
+          <a:prstGeom prst="rect">
+            <a:avLst/>
+          </a:prstGeom>
+          <a:noFill/>
+        </p:spPr>
+        <p:txBody>
+          <a:bodyPr wrap="square">
+            <a:spAutoFit/>
+          </a:bodyPr>
+          <a:lstStyle/>
+          <a:p>
+            <a:pPr algn="l">
+              <a:spcAft>
+                <a:spcPts val="200"/>
+              </a:spcAft>
+            </a:pPr>
+            <a:r>
+              <a:rPr sz="3000" b="1">
+                <a:solidFill>
+                  <a:srgbClr val="101826"/>
+                </a:solidFill>
+                <a:latin typeface="Segoe UI"/>
+              </a:rPr>
+              <a:t>How the growth model works</a:t>
+            </a:r>
+          </a:p>
+          <a:p>
+            <a:pPr>
+              <a:spcAft>
+                <a:spcPts val="0"/>
+              </a:spcAft>
+            </a:pPr>
+            <a:r>
+              <a:rPr sz="1350" b="0">
+                <a:solidFill>
+                  <a:srgbClr val="1B5FAF"/>
+                </a:solidFill>
+                <a:latin typeface="Segoe UI"/>
+              </a:rPr>
+              <a:t>Learn where the city grew, test on years it never saw, then project</a:t>
+            </a:r>
+          </a:p>
+        </p:txBody>
+      </p:sp>
+      <p:sp>
+        <p:nvSpPr>
+          <p:cNvPr id="4" name="Rectangle 3"/>
+          <p:cNvSpPr/>
+          <p:nvPr/>
+        </p:nvSpPr>
+        <p:spPr>
+          <a:xfrm>
+            <a:off x="640080" y="1298448"/>
+            <a:ext cx="1371600" cy="38100"/>
+          </a:xfrm>
+          <a:prstGeom prst="rect">
+            <a:avLst/>
+          </a:prstGeom>
+          <a:solidFill>
+            <a:srgbClr val="1B5FAF"/>
+          </a:solidFill>
+          <a:ln>
+            <a:noFill/>
+          </a:ln>
+          <a:effectLst/>
+        </p:spPr>
+        <p:style>
+          <a:lnRef idx="1">
+            <a:schemeClr val="accent1"/>
+          </a:lnRef>
+          <a:fillRef idx="3">
+            <a:schemeClr val="accent1"/>
+          </a:fillRef>
+          <a:effectRef idx="2">
+            <a:schemeClr val="accent1"/>
+          </a:effectRef>
+          <a:fontRef idx="minor">
+            <a:schemeClr val="lt1"/>
+          </a:fontRef>
+        </p:style>
+        <p:txBody>
+          <a:bodyPr rtlCol="0" anchor="ctr"/>
+          <a:lstStyle/>
+          <a:p>
+            <a:pPr algn="ctr"/>
+          </a:p>
+        </p:txBody>
+      </p:sp>
+      <p:pic>
+        <p:nvPicPr>
+          <p:cNvPr id="5" name="Picture 4" descr="A5_growth_model.png"/>
+          <p:cNvPicPr>
+            <a:picLocks noChangeAspect="1"/>
+          </p:cNvPicPr>
+          <p:nvPr/>
+        </p:nvPicPr>
+        <p:blipFill>
+          <a:blip r:embed="rId2"/>
+          <a:stretch>
+            <a:fillRect/>
+          </a:stretch>
+        </p:blipFill>
+        <p:spPr>
+          <a:xfrm>
+            <a:off x="2057123" y="1508760"/>
+            <a:ext cx="8077449" cy="4709160"/>
+          </a:xfrm>
+          <a:prstGeom prst="rect">
+            <a:avLst/>
+          </a:prstGeom>
+        </p:spPr>
+      </p:pic>
+      <p:sp>
+        <p:nvSpPr>
+          <p:cNvPr id="6" name="TextBox 5"/>
+          <p:cNvSpPr txBox="1"/>
+          <p:nvPr/>
+        </p:nvSpPr>
+        <p:spPr>
+          <a:xfrm>
+            <a:off x="640080" y="6291072"/>
+            <a:ext cx="10972800" cy="274320"/>
+          </a:xfrm>
+          <a:prstGeom prst="rect">
+            <a:avLst/>
+          </a:prstGeom>
+          <a:noFill/>
+        </p:spPr>
+        <p:txBody>
+          <a:bodyPr wrap="square">
+            <a:spAutoFit/>
+          </a:bodyPr>
+          <a:lstStyle/>
+          <a:p>
+            <a:pPr algn="l">
+              <a:spcAft>
+                <a:spcPts val="0"/>
+              </a:spcAft>
+            </a:pPr>
+            <a:r>
+              <a:rPr sz="950" b="0">
+                <a:solidFill>
+                  <a:srgbClr val="5A6474"/>
+                </a:solidFill>
+                <a:latin typeface="Segoe UI"/>
+              </a:rPr>
+              <a:t>Which years feed which step: docs/diagrams/A8_temporal_design.png.</a:t>
+            </a:r>
+          </a:p>
+        </p:txBody>
+      </p:sp>
+    </p:spTree>
+  </p:cSld>
+  <p:clrMapOvr>
+    <a:masterClrMapping/>
+  </p:clrMapOvr>
+</p:sld>
+</file>
+
+<file path=ppt/slides/slide13.xml><?xml version="1.0" encoding="utf-8"?>
 <p:sld xmlns:a="http://schemas.openxmlformats.org/drawingml/2006/main" xmlns:p="http://schemas.openxmlformats.org/presentationml/2006/main" xmlns:r="http://schemas.openxmlformats.org/officeDocument/2006/relationships">
   <p:cSld>
     <p:spTree>
@@ -4208,7 +5350,7 @@
 </p:sld>
 </file>
 
-<file path=ppt/slides/slide11.xml><?xml version="1.0" encoding="utf-8"?>
+<file path=ppt/slides/slide14.xml><?xml version="1.0" encoding="utf-8"?>
 <p:sld xmlns:a="http://schemas.openxmlformats.org/drawingml/2006/main" xmlns:p="http://schemas.openxmlformats.org/presentationml/2006/main" xmlns:r="http://schemas.openxmlformats.org/officeDocument/2006/relationships">
   <p:cSld>
     <p:spTree>
@@ -4651,7 +5793,7 @@
 </p:sld>
 </file>
 
-<file path=ppt/slides/slide12.xml><?xml version="1.0" encoding="utf-8"?>
+<file path=ppt/slides/slide15.xml><?xml version="1.0" encoding="utf-8"?>
 <p:sld xmlns:a="http://schemas.openxmlformats.org/drawingml/2006/main" xmlns:p="http://schemas.openxmlformats.org/presentationml/2006/main" xmlns:r="http://schemas.openxmlformats.org/officeDocument/2006/relationships">
   <p:cSld>
     <p:spTree>
@@ -5180,7 +6322,231 @@
 </p:sld>
 </file>
 
-<file path=ppt/slides/slide13.xml><?xml version="1.0" encoding="utf-8"?>
+<file path=ppt/slides/slide16.xml><?xml version="1.0" encoding="utf-8"?>
+<p:sld xmlns:a="http://schemas.openxmlformats.org/drawingml/2006/main" xmlns:p="http://schemas.openxmlformats.org/presentationml/2006/main" xmlns:r="http://schemas.openxmlformats.org/officeDocument/2006/relationships">
+  <p:cSld>
+    <p:spTree>
+      <p:nvGrpSpPr>
+        <p:cNvPr id="1" name=""/>
+        <p:cNvGrpSpPr/>
+        <p:nvPr/>
+      </p:nvGrpSpPr>
+      <p:grpSpPr/>
+      <p:sp>
+        <p:nvSpPr>
+          <p:cNvPr id="2" name="Rectangle 1"/>
+          <p:cNvSpPr/>
+          <p:nvPr/>
+        </p:nvSpPr>
+        <p:spPr>
+          <a:xfrm>
+            <a:off x="0" y="0"/>
+            <a:ext cx="12191695" cy="6858000"/>
+          </a:xfrm>
+          <a:prstGeom prst="rect">
+            <a:avLst/>
+          </a:prstGeom>
+          <a:solidFill>
+            <a:srgbClr val="FFFFFF"/>
+          </a:solidFill>
+          <a:ln>
+            <a:noFill/>
+          </a:ln>
+          <a:effectLst/>
+        </p:spPr>
+        <p:style>
+          <a:lnRef idx="1">
+            <a:schemeClr val="accent1"/>
+          </a:lnRef>
+          <a:fillRef idx="3">
+            <a:schemeClr val="accent1"/>
+          </a:fillRef>
+          <a:effectRef idx="2">
+            <a:schemeClr val="accent1"/>
+          </a:effectRef>
+          <a:fontRef idx="minor">
+            <a:schemeClr val="lt1"/>
+          </a:fontRef>
+        </p:style>
+        <p:txBody>
+          <a:bodyPr rtlCol="0" anchor="ctr"/>
+          <a:lstStyle/>
+          <a:p>
+            <a:pPr algn="ctr"/>
+          </a:p>
+        </p:txBody>
+      </p:sp>
+      <p:sp>
+        <p:nvSpPr>
+          <p:cNvPr id="3" name="TextBox 2"/>
+          <p:cNvSpPr txBox="1"/>
+          <p:nvPr/>
+        </p:nvSpPr>
+        <p:spPr>
+          <a:xfrm>
+            <a:off x="640080" y="384048"/>
+            <a:ext cx="10972800" cy="822960"/>
+          </a:xfrm>
+          <a:prstGeom prst="rect">
+            <a:avLst/>
+          </a:prstGeom>
+          <a:noFill/>
+        </p:spPr>
+        <p:txBody>
+          <a:bodyPr wrap="square">
+            <a:spAutoFit/>
+          </a:bodyPr>
+          <a:lstStyle/>
+          <a:p>
+            <a:pPr algn="l">
+              <a:spcAft>
+                <a:spcPts val="200"/>
+              </a:spcAft>
+            </a:pPr>
+            <a:r>
+              <a:rPr sz="3000" b="1">
+                <a:solidFill>
+                  <a:srgbClr val="101826"/>
+                </a:solidFill>
+                <a:latin typeface="Segoe UI"/>
+              </a:rPr>
+              <a:t>Where we are</a:t>
+            </a:r>
+          </a:p>
+          <a:p>
+            <a:pPr>
+              <a:spcAft>
+                <a:spcPts val="0"/>
+              </a:spcAft>
+            </a:pPr>
+            <a:r>
+              <a:rPr sz="1350" b="0">
+                <a:solidFill>
+                  <a:srgbClr val="1B5FAF"/>
+                </a:solidFill>
+                <a:latin typeface="Segoe UI"/>
+              </a:rPr>
+              <a:t>Phases, reviews and what is left</a:t>
+            </a:r>
+          </a:p>
+        </p:txBody>
+      </p:sp>
+      <p:sp>
+        <p:nvSpPr>
+          <p:cNvPr id="4" name="Rectangle 3"/>
+          <p:cNvSpPr/>
+          <p:nvPr/>
+        </p:nvSpPr>
+        <p:spPr>
+          <a:xfrm>
+            <a:off x="640080" y="1298448"/>
+            <a:ext cx="1371600" cy="38100"/>
+          </a:xfrm>
+          <a:prstGeom prst="rect">
+            <a:avLst/>
+          </a:prstGeom>
+          <a:solidFill>
+            <a:srgbClr val="1B5FAF"/>
+          </a:solidFill>
+          <a:ln>
+            <a:noFill/>
+          </a:ln>
+          <a:effectLst/>
+        </p:spPr>
+        <p:style>
+          <a:lnRef idx="1">
+            <a:schemeClr val="accent1"/>
+          </a:lnRef>
+          <a:fillRef idx="3">
+            <a:schemeClr val="accent1"/>
+          </a:fillRef>
+          <a:effectRef idx="2">
+            <a:schemeClr val="accent1"/>
+          </a:effectRef>
+          <a:fontRef idx="minor">
+            <a:schemeClr val="lt1"/>
+          </a:fontRef>
+        </p:style>
+        <p:txBody>
+          <a:bodyPr rtlCol="0" anchor="ctr"/>
+          <a:lstStyle/>
+          <a:p>
+            <a:pPr algn="ctr"/>
+          </a:p>
+        </p:txBody>
+      </p:sp>
+      <p:pic>
+        <p:nvPicPr>
+          <p:cNvPr id="5" name="Picture 4" descr="P1_roadmap.png"/>
+          <p:cNvPicPr>
+            <a:picLocks noChangeAspect="1"/>
+          </p:cNvPicPr>
+          <p:nvPr/>
+        </p:nvPicPr>
+        <p:blipFill>
+          <a:blip r:embed="rId2"/>
+          <a:stretch>
+            <a:fillRect/>
+          </a:stretch>
+        </p:blipFill>
+        <p:spPr>
+          <a:xfrm>
+            <a:off x="746313" y="1508760"/>
+            <a:ext cx="10699069" cy="4709160"/>
+          </a:xfrm>
+          <a:prstGeom prst="rect">
+            <a:avLst/>
+          </a:prstGeom>
+        </p:spPr>
+      </p:pic>
+      <p:sp>
+        <p:nvSpPr>
+          <p:cNvPr id="6" name="TextBox 5"/>
+          <p:cNvSpPr txBox="1"/>
+          <p:nvPr/>
+        </p:nvSpPr>
+        <p:spPr>
+          <a:xfrm>
+            <a:off x="640080" y="6291072"/>
+            <a:ext cx="10972800" cy="274320"/>
+          </a:xfrm>
+          <a:prstGeom prst="rect">
+            <a:avLst/>
+          </a:prstGeom>
+          <a:noFill/>
+        </p:spPr>
+        <p:txBody>
+          <a:bodyPr wrap="square">
+            <a:spAutoFit/>
+          </a:bodyPr>
+          <a:lstStyle/>
+          <a:p>
+            <a:pPr algn="l">
+              <a:spcAft>
+                <a:spcPts val="0"/>
+              </a:spcAft>
+            </a:pPr>
+            <a:r>
+              <a:rPr sz="950" b="0">
+                <a:solidFill>
+                  <a:srgbClr val="5A6474"/>
+                </a:solidFill>
+                <a:latin typeface="Segoe UI"/>
+              </a:rPr>
+              <a:t>Code size per module: docs/diagrams/P2_implementation_status.png; the one-command run: P4_run_timeline.png.</a:t>
+            </a:r>
+          </a:p>
+        </p:txBody>
+      </p:sp>
+    </p:spTree>
+  </p:cSld>
+  <p:clrMapOvr>
+    <a:masterClrMapping/>
+  </p:clrMapOvr>
+</p:sld>
+</file>
+
+<file path=ppt/slides/slide17.xml><?xml version="1.0" encoding="utf-8"?>
 <p:sld xmlns:a="http://schemas.openxmlformats.org/drawingml/2006/main" xmlns:p="http://schemas.openxmlformats.org/presentationml/2006/main" xmlns:r="http://schemas.openxmlformats.org/officeDocument/2006/relationships">
   <p:cSld>
     <p:spTree>
@@ -7502,6 +8868,230 @@
                 </a:solidFill>
                 <a:latin typeface="Segoe UI"/>
               </a:rPr>
+              <a:t>System architecture</a:t>
+            </a:r>
+          </a:p>
+          <a:p>
+            <a:pPr>
+              <a:spcAft>
+                <a:spcPts val="0"/>
+              </a:spcAft>
+            </a:pPr>
+            <a:r>
+              <a:rPr sz="1350" b="0">
+                <a:solidFill>
+                  <a:srgbClr val="1B5FAF"/>
+                </a:solidFill>
+                <a:latin typeface="Segoe UI"/>
+              </a:rPr>
+              <a:t>Five layers, each a folder of the code</a:t>
+            </a:r>
+          </a:p>
+        </p:txBody>
+      </p:sp>
+      <p:sp>
+        <p:nvSpPr>
+          <p:cNvPr id="4" name="Rectangle 3"/>
+          <p:cNvSpPr/>
+          <p:nvPr/>
+        </p:nvSpPr>
+        <p:spPr>
+          <a:xfrm>
+            <a:off x="640080" y="1298448"/>
+            <a:ext cx="1371600" cy="38100"/>
+          </a:xfrm>
+          <a:prstGeom prst="rect">
+            <a:avLst/>
+          </a:prstGeom>
+          <a:solidFill>
+            <a:srgbClr val="1B5FAF"/>
+          </a:solidFill>
+          <a:ln>
+            <a:noFill/>
+          </a:ln>
+          <a:effectLst/>
+        </p:spPr>
+        <p:style>
+          <a:lnRef idx="1">
+            <a:schemeClr val="accent1"/>
+          </a:lnRef>
+          <a:fillRef idx="3">
+            <a:schemeClr val="accent1"/>
+          </a:fillRef>
+          <a:effectRef idx="2">
+            <a:schemeClr val="accent1"/>
+          </a:effectRef>
+          <a:fontRef idx="minor">
+            <a:schemeClr val="lt1"/>
+          </a:fontRef>
+        </p:style>
+        <p:txBody>
+          <a:bodyPr rtlCol="0" anchor="ctr"/>
+          <a:lstStyle/>
+          <a:p>
+            <a:pPr algn="ctr"/>
+          </a:p>
+        </p:txBody>
+      </p:sp>
+      <p:pic>
+        <p:nvPicPr>
+          <p:cNvPr id="5" name="Picture 4" descr="A1_system_architecture.png"/>
+          <p:cNvPicPr>
+            <a:picLocks noChangeAspect="1"/>
+          </p:cNvPicPr>
+          <p:nvPr/>
+        </p:nvPicPr>
+        <p:blipFill>
+          <a:blip r:embed="rId2"/>
+          <a:stretch>
+            <a:fillRect/>
+          </a:stretch>
+        </p:blipFill>
+        <p:spPr>
+          <a:xfrm>
+            <a:off x="2057123" y="1508760"/>
+            <a:ext cx="8077449" cy="4709160"/>
+          </a:xfrm>
+          <a:prstGeom prst="rect">
+            <a:avLst/>
+          </a:prstGeom>
+        </p:spPr>
+      </p:pic>
+      <p:sp>
+        <p:nvSpPr>
+          <p:cNvPr id="6" name="TextBox 5"/>
+          <p:cNvSpPr txBox="1"/>
+          <p:nvPr/>
+        </p:nvSpPr>
+        <p:spPr>
+          <a:xfrm>
+            <a:off x="640080" y="6291072"/>
+            <a:ext cx="10972800" cy="274320"/>
+          </a:xfrm>
+          <a:prstGeom prst="rect">
+            <a:avLst/>
+          </a:prstGeom>
+          <a:noFill/>
+        </p:spPr>
+        <p:txBody>
+          <a:bodyPr wrap="square">
+            <a:spAutoFit/>
+          </a:bodyPr>
+          <a:lstStyle/>
+          <a:p>
+            <a:pPr algn="l">
+              <a:spcAft>
+                <a:spcPts val="0"/>
+              </a:spcAft>
+            </a:pPr>
+            <a:r>
+              <a:rPr sz="950" b="0">
+                <a:solidFill>
+                  <a:srgbClr val="5A6474"/>
+                </a:solidFill>
+                <a:latin typeface="Segoe UI"/>
+              </a:rPr>
+              <a:t>Data flow stage by stage: docs/diagrams/A2_pipeline_dataflow.png. All 15 diagrams are explained in docs/DIAGRAMS.md.</a:t>
+            </a:r>
+          </a:p>
+        </p:txBody>
+      </p:sp>
+    </p:spTree>
+  </p:cSld>
+  <p:clrMapOvr>
+    <a:masterClrMapping/>
+  </p:clrMapOvr>
+</p:sld>
+</file>
+
+<file path=ppt/slides/slide5.xml><?xml version="1.0" encoding="utf-8"?>
+<p:sld xmlns:a="http://schemas.openxmlformats.org/drawingml/2006/main" xmlns:p="http://schemas.openxmlformats.org/presentationml/2006/main" xmlns:r="http://schemas.openxmlformats.org/officeDocument/2006/relationships">
+  <p:cSld>
+    <p:spTree>
+      <p:nvGrpSpPr>
+        <p:cNvPr id="1" name=""/>
+        <p:cNvGrpSpPr/>
+        <p:nvPr/>
+      </p:nvGrpSpPr>
+      <p:grpSpPr/>
+      <p:sp>
+        <p:nvSpPr>
+          <p:cNvPr id="2" name="Rectangle 1"/>
+          <p:cNvSpPr/>
+          <p:nvPr/>
+        </p:nvSpPr>
+        <p:spPr>
+          <a:xfrm>
+            <a:off x="0" y="0"/>
+            <a:ext cx="12191695" cy="6858000"/>
+          </a:xfrm>
+          <a:prstGeom prst="rect">
+            <a:avLst/>
+          </a:prstGeom>
+          <a:solidFill>
+            <a:srgbClr val="FFFFFF"/>
+          </a:solidFill>
+          <a:ln>
+            <a:noFill/>
+          </a:ln>
+          <a:effectLst/>
+        </p:spPr>
+        <p:style>
+          <a:lnRef idx="1">
+            <a:schemeClr val="accent1"/>
+          </a:lnRef>
+          <a:fillRef idx="3">
+            <a:schemeClr val="accent1"/>
+          </a:fillRef>
+          <a:effectRef idx="2">
+            <a:schemeClr val="accent1"/>
+          </a:effectRef>
+          <a:fontRef idx="minor">
+            <a:schemeClr val="lt1"/>
+          </a:fontRef>
+        </p:style>
+        <p:txBody>
+          <a:bodyPr rtlCol="0" anchor="ctr"/>
+          <a:lstStyle/>
+          <a:p>
+            <a:pPr algn="ctr"/>
+          </a:p>
+        </p:txBody>
+      </p:sp>
+      <p:sp>
+        <p:nvSpPr>
+          <p:cNvPr id="3" name="TextBox 2"/>
+          <p:cNvSpPr txBox="1"/>
+          <p:nvPr/>
+        </p:nvSpPr>
+        <p:spPr>
+          <a:xfrm>
+            <a:off x="640080" y="384048"/>
+            <a:ext cx="10972800" cy="822960"/>
+          </a:xfrm>
+          <a:prstGeom prst="rect">
+            <a:avLst/>
+          </a:prstGeom>
+          <a:noFill/>
+        </p:spPr>
+        <p:txBody>
+          <a:bodyPr wrap="square">
+            <a:spAutoFit/>
+          </a:bodyPr>
+          <a:lstStyle/>
+          <a:p>
+            <a:pPr algn="l">
+              <a:spcAft>
+                <a:spcPts val="200"/>
+              </a:spcAft>
+            </a:pPr>
+            <a:r>
+              <a:rPr sz="3000" b="1">
+                <a:solidFill>
+                  <a:srgbClr val="101826"/>
+                </a:solidFill>
+                <a:latin typeface="Segoe UI"/>
+              </a:rPr>
               <a:t>Datasets</a:t>
             </a:r>
           </a:p>
@@ -8136,7 +9726,7 @@
 </p:sld>
 </file>
 
-<file path=ppt/slides/slide5.xml><?xml version="1.0" encoding="utf-8"?>
+<file path=ppt/slides/slide6.xml><?xml version="1.0" encoding="utf-8"?>
 <p:sld xmlns:a="http://schemas.openxmlformats.org/drawingml/2006/main" xmlns:p="http://schemas.openxmlformats.org/presentationml/2006/main" xmlns:r="http://schemas.openxmlformats.org/officeDocument/2006/relationships">
   <p:cSld>
     <p:spTree>
@@ -9032,634 +10622,6 @@
 </p:sld>
 </file>
 
-<file path=ppt/slides/slide6.xml><?xml version="1.0" encoding="utf-8"?>
-<p:sld xmlns:a="http://schemas.openxmlformats.org/drawingml/2006/main" xmlns:p="http://schemas.openxmlformats.org/presentationml/2006/main" xmlns:r="http://schemas.openxmlformats.org/officeDocument/2006/relationships">
-  <p:cSld>
-    <p:spTree>
-      <p:nvGrpSpPr>
-        <p:cNvPr id="1" name=""/>
-        <p:cNvGrpSpPr/>
-        <p:nvPr/>
-      </p:nvGrpSpPr>
-      <p:grpSpPr/>
-      <p:sp>
-        <p:nvSpPr>
-          <p:cNvPr id="2" name="Rectangle 1"/>
-          <p:cNvSpPr/>
-          <p:nvPr/>
-        </p:nvSpPr>
-        <p:spPr>
-          <a:xfrm>
-            <a:off x="0" y="0"/>
-            <a:ext cx="12191695" cy="6858000"/>
-          </a:xfrm>
-          <a:prstGeom prst="rect">
-            <a:avLst/>
-          </a:prstGeom>
-          <a:solidFill>
-            <a:srgbClr val="FFFFFF"/>
-          </a:solidFill>
-          <a:ln>
-            <a:noFill/>
-          </a:ln>
-          <a:effectLst/>
-        </p:spPr>
-        <p:style>
-          <a:lnRef idx="1">
-            <a:schemeClr val="accent1"/>
-          </a:lnRef>
-          <a:fillRef idx="3">
-            <a:schemeClr val="accent1"/>
-          </a:fillRef>
-          <a:effectRef idx="2">
-            <a:schemeClr val="accent1"/>
-          </a:effectRef>
-          <a:fontRef idx="minor">
-            <a:schemeClr val="lt1"/>
-          </a:fontRef>
-        </p:style>
-        <p:txBody>
-          <a:bodyPr rtlCol="0" anchor="ctr"/>
-          <a:lstStyle/>
-          <a:p>
-            <a:pPr algn="ctr"/>
-          </a:p>
-        </p:txBody>
-      </p:sp>
-      <p:sp>
-        <p:nvSpPr>
-          <p:cNvPr id="3" name="TextBox 2"/>
-          <p:cNvSpPr txBox="1"/>
-          <p:nvPr/>
-        </p:nvSpPr>
-        <p:spPr>
-          <a:xfrm>
-            <a:off x="640080" y="384048"/>
-            <a:ext cx="10972800" cy="822960"/>
-          </a:xfrm>
-          <a:prstGeom prst="rect">
-            <a:avLst/>
-          </a:prstGeom>
-          <a:noFill/>
-        </p:spPr>
-        <p:txBody>
-          <a:bodyPr wrap="square">
-            <a:spAutoFit/>
-          </a:bodyPr>
-          <a:lstStyle/>
-          <a:p>
-            <a:pPr algn="l">
-              <a:spcAft>
-                <a:spcPts val="200"/>
-              </a:spcAft>
-            </a:pPr>
-            <a:r>
-              <a:rPr sz="3000" b="1">
-                <a:solidFill>
-                  <a:srgbClr val="101826"/>
-                </a:solidFill>
-                <a:latin typeface="Segoe UI"/>
-              </a:rPr>
-              <a:t>Urban growth, 2010-2020</a:t>
-            </a:r>
-          </a:p>
-          <a:p>
-            <a:pPr>
-              <a:spcAft>
-                <a:spcPts val="0"/>
-              </a:spcAft>
-            </a:pPr>
-            <a:r>
-              <a:rPr sz="1350" b="0">
-                <a:solidFill>
-                  <a:srgbClr val="1B5FAF"/>
-                </a:solidFill>
-                <a:latin typeface="Segoe UI"/>
-              </a:rPr>
-              <a:t>Observed epochs only</a:t>
-            </a:r>
-          </a:p>
-        </p:txBody>
-      </p:sp>
-      <p:sp>
-        <p:nvSpPr>
-          <p:cNvPr id="4" name="Rectangle 3"/>
-          <p:cNvSpPr/>
-          <p:nvPr/>
-        </p:nvSpPr>
-        <p:spPr>
-          <a:xfrm>
-            <a:off x="640080" y="1298448"/>
-            <a:ext cx="1371600" cy="38100"/>
-          </a:xfrm>
-          <a:prstGeom prst="rect">
-            <a:avLst/>
-          </a:prstGeom>
-          <a:solidFill>
-            <a:srgbClr val="1B5FAF"/>
-          </a:solidFill>
-          <a:ln>
-            <a:noFill/>
-          </a:ln>
-          <a:effectLst/>
-        </p:spPr>
-        <p:style>
-          <a:lnRef idx="1">
-            <a:schemeClr val="accent1"/>
-          </a:lnRef>
-          <a:fillRef idx="3">
-            <a:schemeClr val="accent1"/>
-          </a:fillRef>
-          <a:effectRef idx="2">
-            <a:schemeClr val="accent1"/>
-          </a:effectRef>
-          <a:fontRef idx="minor">
-            <a:schemeClr val="lt1"/>
-          </a:fontRef>
-        </p:style>
-        <p:txBody>
-          <a:bodyPr rtlCol="0" anchor="ctr"/>
-          <a:lstStyle/>
-          <a:p>
-            <a:pPr algn="ctr"/>
-          </a:p>
-        </p:txBody>
-      </p:sp>
-      <p:pic>
-        <p:nvPicPr>
-          <p:cNvPr id="5" name="Picture 4" descr="F01_growth_index.png"/>
-          <p:cNvPicPr>
-            <a:picLocks noChangeAspect="1"/>
-          </p:cNvPicPr>
-          <p:nvPr/>
-        </p:nvPicPr>
-        <p:blipFill>
-          <a:blip r:embed="rId2"/>
-          <a:stretch>
-            <a:fillRect/>
-          </a:stretch>
-        </p:blipFill>
-        <p:spPr>
-          <a:xfrm>
-            <a:off x="640080" y="1645920"/>
-            <a:ext cx="6400800" cy="4398745"/>
-          </a:xfrm>
-          <a:prstGeom prst="rect">
-            <a:avLst/>
-          </a:prstGeom>
-        </p:spPr>
-      </p:pic>
-      <p:sp>
-        <p:nvSpPr>
-          <p:cNvPr id="6" name="Rectangle 5"/>
-          <p:cNvSpPr/>
-          <p:nvPr/>
-        </p:nvSpPr>
-        <p:spPr>
-          <a:xfrm>
-            <a:off x="7406640" y="1737360"/>
-            <a:ext cx="4114800" cy="960120"/>
-          </a:xfrm>
-          <a:prstGeom prst="rect">
-            <a:avLst/>
-          </a:prstGeom>
-          <a:solidFill>
-            <a:srgbClr val="F1F5FA"/>
-          </a:solidFill>
-          <a:ln w="9525">
-            <a:solidFill>
-              <a:srgbClr val="C3CEDC"/>
-            </a:solidFill>
-          </a:ln>
-          <a:effectLst/>
-        </p:spPr>
-        <p:style>
-          <a:lnRef idx="1">
-            <a:schemeClr val="accent1"/>
-          </a:lnRef>
-          <a:fillRef idx="3">
-            <a:schemeClr val="accent1"/>
-          </a:fillRef>
-          <a:effectRef idx="2">
-            <a:schemeClr val="accent1"/>
-          </a:effectRef>
-          <a:fontRef idx="minor">
-            <a:schemeClr val="lt1"/>
-          </a:fontRef>
-        </p:style>
-        <p:txBody>
-          <a:bodyPr rtlCol="0" anchor="ctr"/>
-          <a:lstStyle/>
-          <a:p>
-            <a:pPr algn="ctr"/>
-          </a:p>
-        </p:txBody>
-      </p:sp>
-      <p:sp>
-        <p:nvSpPr>
-          <p:cNvPr id="7" name="TextBox 6"/>
-          <p:cNvSpPr txBox="1"/>
-          <p:nvPr/>
-        </p:nvSpPr>
-        <p:spPr>
-          <a:xfrm>
-            <a:off x="7534656" y="1828800"/>
-            <a:ext cx="3858768" cy="777240"/>
-          </a:xfrm>
-          <a:prstGeom prst="rect">
-            <a:avLst/>
-          </a:prstGeom>
-          <a:noFill/>
-        </p:spPr>
-        <p:txBody>
-          <a:bodyPr wrap="square">
-            <a:spAutoFit/>
-          </a:bodyPr>
-          <a:lstStyle/>
-          <a:p>
-            <a:pPr algn="l">
-              <a:spcAft>
-                <a:spcPts val="200"/>
-              </a:spcAft>
-            </a:pPr>
-            <a:r>
-              <a:rPr sz="2000" b="1">
-                <a:solidFill>
-                  <a:srgbClr val="1B5FAF"/>
-                </a:solidFill>
-                <a:latin typeface="Segoe UI"/>
-              </a:rPr>
-              <a:t>+17.25 km2</a:t>
-            </a:r>
-          </a:p>
-          <a:p>
-            <a:pPr>
-              <a:spcAft>
-                <a:spcPts val="0"/>
-              </a:spcAft>
-            </a:pPr>
-            <a:r>
-              <a:rPr sz="1050" b="0">
-                <a:solidFill>
-                  <a:srgbClr val="5A6474"/>
-                </a:solidFill>
-                <a:latin typeface="Segoe UI"/>
-              </a:rPr>
-              <a:t>built-up surface, 72.48 to 89.73 km2</a:t>
-            </a:r>
-          </a:p>
-        </p:txBody>
-      </p:sp>
-      <p:sp>
-        <p:nvSpPr>
-          <p:cNvPr id="8" name="Rectangle 7"/>
-          <p:cNvSpPr/>
-          <p:nvPr/>
-        </p:nvSpPr>
-        <p:spPr>
-          <a:xfrm>
-            <a:off x="7406640" y="2834640"/>
-            <a:ext cx="4114800" cy="960120"/>
-          </a:xfrm>
-          <a:prstGeom prst="rect">
-            <a:avLst/>
-          </a:prstGeom>
-          <a:solidFill>
-            <a:srgbClr val="F1F5FA"/>
-          </a:solidFill>
-          <a:ln w="9525">
-            <a:solidFill>
-              <a:srgbClr val="C3CEDC"/>
-            </a:solidFill>
-          </a:ln>
-          <a:effectLst/>
-        </p:spPr>
-        <p:style>
-          <a:lnRef idx="1">
-            <a:schemeClr val="accent1"/>
-          </a:lnRef>
-          <a:fillRef idx="3">
-            <a:schemeClr val="accent1"/>
-          </a:fillRef>
-          <a:effectRef idx="2">
-            <a:schemeClr val="accent1"/>
-          </a:effectRef>
-          <a:fontRef idx="minor">
-            <a:schemeClr val="lt1"/>
-          </a:fontRef>
-        </p:style>
-        <p:txBody>
-          <a:bodyPr rtlCol="0" anchor="ctr"/>
-          <a:lstStyle/>
-          <a:p>
-            <a:pPr algn="ctr"/>
-          </a:p>
-        </p:txBody>
-      </p:sp>
-      <p:sp>
-        <p:nvSpPr>
-          <p:cNvPr id="9" name="TextBox 8"/>
-          <p:cNvSpPr txBox="1"/>
-          <p:nvPr/>
-        </p:nvSpPr>
-        <p:spPr>
-          <a:xfrm>
-            <a:off x="7534656" y="2926080"/>
-            <a:ext cx="3858768" cy="777240"/>
-          </a:xfrm>
-          <a:prstGeom prst="rect">
-            <a:avLst/>
-          </a:prstGeom>
-          <a:noFill/>
-        </p:spPr>
-        <p:txBody>
-          <a:bodyPr wrap="square">
-            <a:spAutoFit/>
-          </a:bodyPr>
-          <a:lstStyle/>
-          <a:p>
-            <a:pPr algn="l">
-              <a:spcAft>
-                <a:spcPts val="200"/>
-              </a:spcAft>
-            </a:pPr>
-            <a:r>
-              <a:rPr sz="2000" b="1">
-                <a:solidFill>
-                  <a:srgbClr val="1B5FAF"/>
-                </a:solidFill>
-                <a:latin typeface="Segoe UI"/>
-              </a:rPr>
-              <a:t>1.86 %/yr</a:t>
-            </a:r>
-          </a:p>
-          <a:p>
-            <a:pPr>
-              <a:spcAft>
-                <a:spcPts val="0"/>
-              </a:spcAft>
-            </a:pPr>
-            <a:r>
-              <a:rPr sz="1050" b="0">
-                <a:solidFill>
-                  <a:srgbClr val="5A6474"/>
-                </a:solidFill>
-                <a:latin typeface="Segoe UI"/>
-              </a:rPr>
-              <a:t>urban extent, compound</a:t>
-            </a:r>
-          </a:p>
-        </p:txBody>
-      </p:sp>
-      <p:sp>
-        <p:nvSpPr>
-          <p:cNvPr id="10" name="Rectangle 9"/>
-          <p:cNvSpPr/>
-          <p:nvPr/>
-        </p:nvSpPr>
-        <p:spPr>
-          <a:xfrm>
-            <a:off x="7406640" y="3931920"/>
-            <a:ext cx="4114800" cy="960120"/>
-          </a:xfrm>
-          <a:prstGeom prst="rect">
-            <a:avLst/>
-          </a:prstGeom>
-          <a:solidFill>
-            <a:srgbClr val="F1F5FA"/>
-          </a:solidFill>
-          <a:ln w="9525">
-            <a:solidFill>
-              <a:srgbClr val="C3CEDC"/>
-            </a:solidFill>
-          </a:ln>
-          <a:effectLst/>
-        </p:spPr>
-        <p:style>
-          <a:lnRef idx="1">
-            <a:schemeClr val="accent1"/>
-          </a:lnRef>
-          <a:fillRef idx="3">
-            <a:schemeClr val="accent1"/>
-          </a:fillRef>
-          <a:effectRef idx="2">
-            <a:schemeClr val="accent1"/>
-          </a:effectRef>
-          <a:fontRef idx="minor">
-            <a:schemeClr val="lt1"/>
-          </a:fontRef>
-        </p:style>
-        <p:txBody>
-          <a:bodyPr rtlCol="0" anchor="ctr"/>
-          <a:lstStyle/>
-          <a:p>
-            <a:pPr algn="ctr"/>
-          </a:p>
-        </p:txBody>
-      </p:sp>
-      <p:sp>
-        <p:nvSpPr>
-          <p:cNvPr id="11" name="TextBox 10"/>
-          <p:cNvSpPr txBox="1"/>
-          <p:nvPr/>
-        </p:nvSpPr>
-        <p:spPr>
-          <a:xfrm>
-            <a:off x="7534656" y="4023360"/>
-            <a:ext cx="3858768" cy="777240"/>
-          </a:xfrm>
-          <a:prstGeom prst="rect">
-            <a:avLst/>
-          </a:prstGeom>
-          <a:noFill/>
-        </p:spPr>
-        <p:txBody>
-          <a:bodyPr wrap="square">
-            <a:spAutoFit/>
-          </a:bodyPr>
-          <a:lstStyle/>
-          <a:p>
-            <a:pPr algn="l">
-              <a:spcAft>
-                <a:spcPts val="200"/>
-              </a:spcAft>
-            </a:pPr>
-            <a:r>
-              <a:rPr sz="2000" b="1">
-                <a:solidFill>
-                  <a:srgbClr val="B26A00"/>
-                </a:solidFill>
-                <a:latin typeface="Segoe UI"/>
-              </a:rPr>
-              <a:t>44.3 %</a:t>
-            </a:r>
-          </a:p>
-          <a:p>
-            <a:pPr>
-              <a:spcAft>
-                <a:spcPts val="0"/>
-              </a:spcAft>
-            </a:pPr>
-            <a:r>
-              <a:rPr sz="1050" b="0">
-                <a:solidFill>
-                  <a:srgbClr val="5A6474"/>
-                </a:solidFill>
-                <a:latin typeface="Segoe UI"/>
-              </a:rPr>
-              <a:t>of new urban land is leapfrog - detached from the city</a:t>
-            </a:r>
-          </a:p>
-        </p:txBody>
-      </p:sp>
-      <p:sp>
-        <p:nvSpPr>
-          <p:cNvPr id="12" name="Rectangle 11"/>
-          <p:cNvSpPr/>
-          <p:nvPr/>
-        </p:nvSpPr>
-        <p:spPr>
-          <a:xfrm>
-            <a:off x="7406640" y="5029200"/>
-            <a:ext cx="4114800" cy="960120"/>
-          </a:xfrm>
-          <a:prstGeom prst="rect">
-            <a:avLst/>
-          </a:prstGeom>
-          <a:solidFill>
-            <a:srgbClr val="F1F5FA"/>
-          </a:solidFill>
-          <a:ln w="9525">
-            <a:solidFill>
-              <a:srgbClr val="C3CEDC"/>
-            </a:solidFill>
-          </a:ln>
-          <a:effectLst/>
-        </p:spPr>
-        <p:style>
-          <a:lnRef idx="1">
-            <a:schemeClr val="accent1"/>
-          </a:lnRef>
-          <a:fillRef idx="3">
-            <a:schemeClr val="accent1"/>
-          </a:fillRef>
-          <a:effectRef idx="2">
-            <a:schemeClr val="accent1"/>
-          </a:effectRef>
-          <a:fontRef idx="minor">
-            <a:schemeClr val="lt1"/>
-          </a:fontRef>
-        </p:style>
-        <p:txBody>
-          <a:bodyPr rtlCol="0" anchor="ctr"/>
-          <a:lstStyle/>
-          <a:p>
-            <a:pPr algn="ctr"/>
-          </a:p>
-        </p:txBody>
-      </p:sp>
-      <p:sp>
-        <p:nvSpPr>
-          <p:cNvPr id="13" name="TextBox 12"/>
-          <p:cNvSpPr txBox="1"/>
-          <p:nvPr/>
-        </p:nvSpPr>
-        <p:spPr>
-          <a:xfrm>
-            <a:off x="7534656" y="5120640"/>
-            <a:ext cx="3858768" cy="777240"/>
-          </a:xfrm>
-          <a:prstGeom prst="rect">
-            <a:avLst/>
-          </a:prstGeom>
-          <a:noFill/>
-        </p:spPr>
-        <p:txBody>
-          <a:bodyPr wrap="square">
-            <a:spAutoFit/>
-          </a:bodyPr>
-          <a:lstStyle/>
-          <a:p>
-            <a:pPr algn="l">
-              <a:spcAft>
-                <a:spcPts val="200"/>
-              </a:spcAft>
-            </a:pPr>
-            <a:r>
-              <a:rPr sz="2000" b="1">
-                <a:solidFill>
-                  <a:srgbClr val="0E7A52"/>
-                </a:solidFill>
-                <a:latin typeface="Segoe UI"/>
-              </a:rPr>
-              <a:t>1.3x - 2.3x</a:t>
-            </a:r>
-          </a:p>
-          <a:p>
-            <a:pPr>
-              <a:spcAft>
-                <a:spcPts val="0"/>
-              </a:spcAft>
-            </a:pPr>
-            <a:r>
-              <a:rPr sz="1050" b="0">
-                <a:solidFill>
-                  <a:srgbClr val="5A6474"/>
-                </a:solidFill>
-                <a:latin typeface="Segoe UI"/>
-              </a:rPr>
-              <a:t>faster than population, depending on the population dataset</a:t>
-            </a:r>
-          </a:p>
-        </p:txBody>
-      </p:sp>
-      <p:sp>
-        <p:nvSpPr>
-          <p:cNvPr id="14" name="TextBox 13"/>
-          <p:cNvSpPr txBox="1"/>
-          <p:nvPr/>
-        </p:nvSpPr>
-        <p:spPr>
-          <a:xfrm>
-            <a:off x="640080" y="6291072"/>
-            <a:ext cx="10972800" cy="274320"/>
-          </a:xfrm>
-          <a:prstGeom prst="rect">
-            <a:avLst/>
-          </a:prstGeom>
-          <a:noFill/>
-        </p:spPr>
-        <p:txBody>
-          <a:bodyPr wrap="square">
-            <a:spAutoFit/>
-          </a:bodyPr>
-          <a:lstStyle/>
-          <a:p>
-            <a:pPr algn="l">
-              <a:spcAft>
-                <a:spcPts val="0"/>
-              </a:spcAft>
-            </a:pPr>
-            <a:r>
-              <a:rPr sz="950" b="0">
-                <a:solidFill>
-                  <a:srgbClr val="5A6474"/>
-                </a:solidFill>
-                <a:latin typeface="Segoe UI"/>
-              </a:rPr>
-              <a:t>GHSL 2025 is drawn dashed and labelled: a model projection, not a measurement.</a:t>
-            </a:r>
-          </a:p>
-        </p:txBody>
-      </p:sp>
-    </p:spTree>
-  </p:cSld>
-  <p:clrMapOvr>
-    <a:masterClrMapping/>
-  </p:clrMapOvr>
-</p:sld>
-</file>
-
 <file path=ppt/slides/slide7.xml><?xml version="1.0" encoding="utf-8"?>
 <p:sld xmlns:a="http://schemas.openxmlformats.org/drawingml/2006/main" xmlns:p="http://schemas.openxmlformats.org/presentationml/2006/main" xmlns:r="http://schemas.openxmlformats.org/officeDocument/2006/relationships">
   <p:cSld>
@@ -9748,7 +10710,7 @@
                 </a:solidFill>
                 <a:latin typeface="Segoe UI"/>
               </a:rPr>
-              <a:t>Ghost growth: is the split real?</a:t>
+              <a:t>Urban growth, 2010-2020</a:t>
             </a:r>
           </a:p>
           <a:p>
@@ -9764,7 +10726,7 @@
                 </a:solidFill>
                 <a:latin typeface="Segoe UI"/>
               </a:rPr>
-              <a:t>The rule decides how the same 5.56 km2 of candidates divides</a:t>
+              <a:t>Observed epochs only</a:t>
             </a:r>
           </a:p>
         </p:txBody>
@@ -9815,7 +10777,7 @@
       </p:sp>
       <p:pic>
         <p:nvPicPr>
-          <p:cNvPr id="5" name="Picture 4" descr="F04_rule_sensitivity.png"/>
+          <p:cNvPr id="5" name="Picture 4" descr="F01_growth_index.png"/>
           <p:cNvPicPr>
             <a:picLocks noChangeAspect="1"/>
           </p:cNvPicPr>
@@ -9829,48 +10791,24 @@
         </p:blipFill>
         <p:spPr>
           <a:xfrm>
-            <a:off x="640080" y="1600200"/>
-            <a:ext cx="5486400" cy="3082606"/>
+            <a:off x="640080" y="1645920"/>
+            <a:ext cx="6400800" cy="4398745"/>
           </a:xfrm>
           <a:prstGeom prst="rect">
             <a:avLst/>
           </a:prstGeom>
         </p:spPr>
       </p:pic>
-      <p:pic>
-        <p:nvPicPr>
-          <p:cNvPr id="6" name="Picture 5" descr="F05_holdout.png"/>
-          <p:cNvPicPr>
-            <a:picLocks noChangeAspect="1"/>
-          </p:cNvPicPr>
-          <p:nvPr/>
-        </p:nvPicPr>
-        <p:blipFill>
-          <a:blip r:embed="rId3"/>
-          <a:stretch>
-            <a:fillRect/>
-          </a:stretch>
-        </p:blipFill>
-        <p:spPr>
-          <a:xfrm>
-            <a:off x="6309360" y="1600200"/>
-            <a:ext cx="5486400" cy="2792555"/>
-          </a:xfrm>
-          <a:prstGeom prst="rect">
-            <a:avLst/>
-          </a:prstGeom>
-        </p:spPr>
-      </p:pic>
-      <p:sp>
-        <p:nvSpPr>
-          <p:cNvPr id="7" name="Rectangle 6"/>
+      <p:sp>
+        <p:nvSpPr>
+          <p:cNvPr id="6" name="Rectangle 5"/>
           <p:cNvSpPr/>
           <p:nvPr/>
         </p:nvSpPr>
         <p:spPr>
           <a:xfrm>
-            <a:off x="640080" y="4846320"/>
-            <a:ext cx="10881360" cy="1371600"/>
+            <a:off x="7406640" y="1737360"/>
+            <a:ext cx="4114800" cy="960120"/>
           </a:xfrm>
           <a:prstGeom prst="rect">
             <a:avLst/>
@@ -9880,7 +10818,7 @@
           </a:solidFill>
           <a:ln w="9525">
             <a:solidFill>
-              <a:srgbClr val="D5DDE8"/>
+              <a:srgbClr val="C3CEDC"/>
             </a:solidFill>
           </a:ln>
           <a:effectLst/>
@@ -9909,14 +10847,14 @@
       </p:sp>
       <p:sp>
         <p:nvSpPr>
-          <p:cNvPr id="8" name="TextBox 7"/>
+          <p:cNvPr id="7" name="TextBox 6"/>
           <p:cNvSpPr txBox="1"/>
           <p:nvPr/>
         </p:nvSpPr>
         <p:spPr>
           <a:xfrm>
-            <a:off x="868680" y="4983480"/>
-            <a:ext cx="10424160" cy="1143000"/>
+            <a:off x="7534656" y="1828800"/>
+            <a:ext cx="3858768" cy="777240"/>
           </a:xfrm>
           <a:prstGeom prst="rect">
             <a:avLst/>
@@ -9931,17 +10869,17 @@
           <a:p>
             <a:pPr algn="l">
               <a:spcAft>
-                <a:spcPts val="400"/>
-              </a:spcAft>
-            </a:pPr>
-            <a:r>
-              <a:rPr sz="1400" b="1">
-                <a:solidFill>
-                  <a:srgbClr val="101826"/>
-                </a:solidFill>
-                <a:latin typeface="Segoe UI"/>
-              </a:rPr>
-              <a:t>Hold-out test: classify with the 2013-2020 night lights only, then check what happened next.</a:t>
+                <a:spcPts val="200"/>
+              </a:spcAft>
+            </a:pPr>
+            <a:r>
+              <a:rPr sz="2000" b="1">
+                <a:solidFill>
+                  <a:srgbClr val="1B5FAF"/>
+                </a:solidFill>
+                <a:latin typeface="Segoe UI"/>
+              </a:rPr>
+              <a:t>+17.25 km2</a:t>
             </a:r>
           </a:p>
           <a:p>
@@ -9951,13 +10889,355 @@
               </a:spcAft>
             </a:pPr>
             <a:r>
-              <a:rPr sz="1250" b="0">
+              <a:rPr sz="1050" b="0">
                 <a:solidFill>
                   <a:srgbClr val="5A6474"/>
                 </a:solidFill>
                 <a:latin typeface="Segoe UI"/>
               </a:rPr>
-              <a:t>Cells called emerging went on to brighten, relative to the city, more than cells called ghost growth: p = 0.010 over 100 m cells and p = 0.031 over 500 m blocks. The split carries real information - and the effect is modest: an emerging cell out-brightened a ghost cell 56% of the time. It is a screening map, not a verdict.</a:t>
+              <a:t>built-up surface, 72.48 to 89.73 km2</a:t>
+            </a:r>
+          </a:p>
+        </p:txBody>
+      </p:sp>
+      <p:sp>
+        <p:nvSpPr>
+          <p:cNvPr id="8" name="Rectangle 7"/>
+          <p:cNvSpPr/>
+          <p:nvPr/>
+        </p:nvSpPr>
+        <p:spPr>
+          <a:xfrm>
+            <a:off x="7406640" y="2834640"/>
+            <a:ext cx="4114800" cy="960120"/>
+          </a:xfrm>
+          <a:prstGeom prst="rect">
+            <a:avLst/>
+          </a:prstGeom>
+          <a:solidFill>
+            <a:srgbClr val="F1F5FA"/>
+          </a:solidFill>
+          <a:ln w="9525">
+            <a:solidFill>
+              <a:srgbClr val="C3CEDC"/>
+            </a:solidFill>
+          </a:ln>
+          <a:effectLst/>
+        </p:spPr>
+        <p:style>
+          <a:lnRef idx="1">
+            <a:schemeClr val="accent1"/>
+          </a:lnRef>
+          <a:fillRef idx="3">
+            <a:schemeClr val="accent1"/>
+          </a:fillRef>
+          <a:effectRef idx="2">
+            <a:schemeClr val="accent1"/>
+          </a:effectRef>
+          <a:fontRef idx="minor">
+            <a:schemeClr val="lt1"/>
+          </a:fontRef>
+        </p:style>
+        <p:txBody>
+          <a:bodyPr rtlCol="0" anchor="ctr"/>
+          <a:lstStyle/>
+          <a:p>
+            <a:pPr algn="ctr"/>
+          </a:p>
+        </p:txBody>
+      </p:sp>
+      <p:sp>
+        <p:nvSpPr>
+          <p:cNvPr id="9" name="TextBox 8"/>
+          <p:cNvSpPr txBox="1"/>
+          <p:nvPr/>
+        </p:nvSpPr>
+        <p:spPr>
+          <a:xfrm>
+            <a:off x="7534656" y="2926080"/>
+            <a:ext cx="3858768" cy="777240"/>
+          </a:xfrm>
+          <a:prstGeom prst="rect">
+            <a:avLst/>
+          </a:prstGeom>
+          <a:noFill/>
+        </p:spPr>
+        <p:txBody>
+          <a:bodyPr wrap="square">
+            <a:spAutoFit/>
+          </a:bodyPr>
+          <a:lstStyle/>
+          <a:p>
+            <a:pPr algn="l">
+              <a:spcAft>
+                <a:spcPts val="200"/>
+              </a:spcAft>
+            </a:pPr>
+            <a:r>
+              <a:rPr sz="2000" b="1">
+                <a:solidFill>
+                  <a:srgbClr val="1B5FAF"/>
+                </a:solidFill>
+                <a:latin typeface="Segoe UI"/>
+              </a:rPr>
+              <a:t>1.86 %/yr</a:t>
+            </a:r>
+          </a:p>
+          <a:p>
+            <a:pPr>
+              <a:spcAft>
+                <a:spcPts val="0"/>
+              </a:spcAft>
+            </a:pPr>
+            <a:r>
+              <a:rPr sz="1050" b="0">
+                <a:solidFill>
+                  <a:srgbClr val="5A6474"/>
+                </a:solidFill>
+                <a:latin typeface="Segoe UI"/>
+              </a:rPr>
+              <a:t>urban extent, compound</a:t>
+            </a:r>
+          </a:p>
+        </p:txBody>
+      </p:sp>
+      <p:sp>
+        <p:nvSpPr>
+          <p:cNvPr id="10" name="Rectangle 9"/>
+          <p:cNvSpPr/>
+          <p:nvPr/>
+        </p:nvSpPr>
+        <p:spPr>
+          <a:xfrm>
+            <a:off x="7406640" y="3931920"/>
+            <a:ext cx="4114800" cy="960120"/>
+          </a:xfrm>
+          <a:prstGeom prst="rect">
+            <a:avLst/>
+          </a:prstGeom>
+          <a:solidFill>
+            <a:srgbClr val="F1F5FA"/>
+          </a:solidFill>
+          <a:ln w="9525">
+            <a:solidFill>
+              <a:srgbClr val="C3CEDC"/>
+            </a:solidFill>
+          </a:ln>
+          <a:effectLst/>
+        </p:spPr>
+        <p:style>
+          <a:lnRef idx="1">
+            <a:schemeClr val="accent1"/>
+          </a:lnRef>
+          <a:fillRef idx="3">
+            <a:schemeClr val="accent1"/>
+          </a:fillRef>
+          <a:effectRef idx="2">
+            <a:schemeClr val="accent1"/>
+          </a:effectRef>
+          <a:fontRef idx="minor">
+            <a:schemeClr val="lt1"/>
+          </a:fontRef>
+        </p:style>
+        <p:txBody>
+          <a:bodyPr rtlCol="0" anchor="ctr"/>
+          <a:lstStyle/>
+          <a:p>
+            <a:pPr algn="ctr"/>
+          </a:p>
+        </p:txBody>
+      </p:sp>
+      <p:sp>
+        <p:nvSpPr>
+          <p:cNvPr id="11" name="TextBox 10"/>
+          <p:cNvSpPr txBox="1"/>
+          <p:nvPr/>
+        </p:nvSpPr>
+        <p:spPr>
+          <a:xfrm>
+            <a:off x="7534656" y="4023360"/>
+            <a:ext cx="3858768" cy="777240"/>
+          </a:xfrm>
+          <a:prstGeom prst="rect">
+            <a:avLst/>
+          </a:prstGeom>
+          <a:noFill/>
+        </p:spPr>
+        <p:txBody>
+          <a:bodyPr wrap="square">
+            <a:spAutoFit/>
+          </a:bodyPr>
+          <a:lstStyle/>
+          <a:p>
+            <a:pPr algn="l">
+              <a:spcAft>
+                <a:spcPts val="200"/>
+              </a:spcAft>
+            </a:pPr>
+            <a:r>
+              <a:rPr sz="2000" b="1">
+                <a:solidFill>
+                  <a:srgbClr val="B26A00"/>
+                </a:solidFill>
+                <a:latin typeface="Segoe UI"/>
+              </a:rPr>
+              <a:t>44.3 %</a:t>
+            </a:r>
+          </a:p>
+          <a:p>
+            <a:pPr>
+              <a:spcAft>
+                <a:spcPts val="0"/>
+              </a:spcAft>
+            </a:pPr>
+            <a:r>
+              <a:rPr sz="1050" b="0">
+                <a:solidFill>
+                  <a:srgbClr val="5A6474"/>
+                </a:solidFill>
+                <a:latin typeface="Segoe UI"/>
+              </a:rPr>
+              <a:t>of new urban land is leapfrog - detached from the city</a:t>
+            </a:r>
+          </a:p>
+        </p:txBody>
+      </p:sp>
+      <p:sp>
+        <p:nvSpPr>
+          <p:cNvPr id="12" name="Rectangle 11"/>
+          <p:cNvSpPr/>
+          <p:nvPr/>
+        </p:nvSpPr>
+        <p:spPr>
+          <a:xfrm>
+            <a:off x="7406640" y="5029200"/>
+            <a:ext cx="4114800" cy="960120"/>
+          </a:xfrm>
+          <a:prstGeom prst="rect">
+            <a:avLst/>
+          </a:prstGeom>
+          <a:solidFill>
+            <a:srgbClr val="F1F5FA"/>
+          </a:solidFill>
+          <a:ln w="9525">
+            <a:solidFill>
+              <a:srgbClr val="C3CEDC"/>
+            </a:solidFill>
+          </a:ln>
+          <a:effectLst/>
+        </p:spPr>
+        <p:style>
+          <a:lnRef idx="1">
+            <a:schemeClr val="accent1"/>
+          </a:lnRef>
+          <a:fillRef idx="3">
+            <a:schemeClr val="accent1"/>
+          </a:fillRef>
+          <a:effectRef idx="2">
+            <a:schemeClr val="accent1"/>
+          </a:effectRef>
+          <a:fontRef idx="minor">
+            <a:schemeClr val="lt1"/>
+          </a:fontRef>
+        </p:style>
+        <p:txBody>
+          <a:bodyPr rtlCol="0" anchor="ctr"/>
+          <a:lstStyle/>
+          <a:p>
+            <a:pPr algn="ctr"/>
+          </a:p>
+        </p:txBody>
+      </p:sp>
+      <p:sp>
+        <p:nvSpPr>
+          <p:cNvPr id="13" name="TextBox 12"/>
+          <p:cNvSpPr txBox="1"/>
+          <p:nvPr/>
+        </p:nvSpPr>
+        <p:spPr>
+          <a:xfrm>
+            <a:off x="7534656" y="5120640"/>
+            <a:ext cx="3858768" cy="777240"/>
+          </a:xfrm>
+          <a:prstGeom prst="rect">
+            <a:avLst/>
+          </a:prstGeom>
+          <a:noFill/>
+        </p:spPr>
+        <p:txBody>
+          <a:bodyPr wrap="square">
+            <a:spAutoFit/>
+          </a:bodyPr>
+          <a:lstStyle/>
+          <a:p>
+            <a:pPr algn="l">
+              <a:spcAft>
+                <a:spcPts val="200"/>
+              </a:spcAft>
+            </a:pPr>
+            <a:r>
+              <a:rPr sz="2000" b="1">
+                <a:solidFill>
+                  <a:srgbClr val="0E7A52"/>
+                </a:solidFill>
+                <a:latin typeface="Segoe UI"/>
+              </a:rPr>
+              <a:t>1.3x - 2.3x</a:t>
+            </a:r>
+          </a:p>
+          <a:p>
+            <a:pPr>
+              <a:spcAft>
+                <a:spcPts val="0"/>
+              </a:spcAft>
+            </a:pPr>
+            <a:r>
+              <a:rPr sz="1050" b="0">
+                <a:solidFill>
+                  <a:srgbClr val="5A6474"/>
+                </a:solidFill>
+                <a:latin typeface="Segoe UI"/>
+              </a:rPr>
+              <a:t>faster than population, depending on the population dataset</a:t>
+            </a:r>
+          </a:p>
+        </p:txBody>
+      </p:sp>
+      <p:sp>
+        <p:nvSpPr>
+          <p:cNvPr id="14" name="TextBox 13"/>
+          <p:cNvSpPr txBox="1"/>
+          <p:nvPr/>
+        </p:nvSpPr>
+        <p:spPr>
+          <a:xfrm>
+            <a:off x="640080" y="6291072"/>
+            <a:ext cx="10972800" cy="274320"/>
+          </a:xfrm>
+          <a:prstGeom prst="rect">
+            <a:avLst/>
+          </a:prstGeom>
+          <a:noFill/>
+        </p:spPr>
+        <p:txBody>
+          <a:bodyPr wrap="square">
+            <a:spAutoFit/>
+          </a:bodyPr>
+          <a:lstStyle/>
+          <a:p>
+            <a:pPr algn="l">
+              <a:spcAft>
+                <a:spcPts val="0"/>
+              </a:spcAft>
+            </a:pPr>
+            <a:r>
+              <a:rPr sz="950" b="0">
+                <a:solidFill>
+                  <a:srgbClr val="5A6474"/>
+                </a:solidFill>
+                <a:latin typeface="Segoe UI"/>
+              </a:rPr>
+              <a:t>GHSL 2025 is drawn dashed and labelled: a model projection, not a measurement.</a:t>
             </a:r>
           </a:p>
         </p:txBody>
@@ -10058,7 +11338,7 @@
                 </a:solidFill>
                 <a:latin typeface="Segoe UI"/>
               </a:rPr>
-              <a:t>What a flagged zone actually looks like</a:t>
+              <a:t>How a cell is classified</a:t>
             </a:r>
           </a:p>
           <a:p>
@@ -10074,7 +11354,7 @@
                 </a:solidFill>
                 <a:latin typeface="Segoe UI"/>
               </a:rPr>
-              <a:t>One evidence card of 23</a:t>
+              <a:t>The ghost-growth typology, per 100 m cell</a:t>
             </a:r>
           </a:p>
         </p:txBody>
@@ -10125,7 +11405,7 @@
       </p:sp>
       <p:pic>
         <p:nvPicPr>
-          <p:cNvPr id="5" name="Picture 4" descr="zone_01.png"/>
+          <p:cNvPr id="5" name="Picture 4" descr="A3_ghost_typology_algorithm.png"/>
           <p:cNvPicPr>
             <a:picLocks noChangeAspect="1"/>
           </p:cNvPicPr>
@@ -10139,8 +11419,8 @@
         </p:blipFill>
         <p:spPr>
           <a:xfrm>
-            <a:off x="640080" y="1600200"/>
-            <a:ext cx="7772400" cy="4902591"/>
+            <a:off x="2220304" y="1508760"/>
+            <a:ext cx="7751087" cy="4709160"/>
           </a:xfrm>
           <a:prstGeom prst="rect">
             <a:avLst/>
@@ -10149,60 +11429,14 @@
       </p:pic>
       <p:sp>
         <p:nvSpPr>
-          <p:cNvPr id="6" name="Rectangle 5"/>
-          <p:cNvSpPr/>
-          <p:nvPr/>
-        </p:nvSpPr>
-        <p:spPr>
-          <a:xfrm>
-            <a:off x="8686800" y="1737360"/>
-            <a:ext cx="2834640" cy="960120"/>
-          </a:xfrm>
-          <a:prstGeom prst="rect">
-            <a:avLst/>
-          </a:prstGeom>
-          <a:solidFill>
-            <a:srgbClr val="F1F5FA"/>
-          </a:solidFill>
-          <a:ln w="9525">
-            <a:solidFill>
-              <a:srgbClr val="C3CEDC"/>
-            </a:solidFill>
-          </a:ln>
-          <a:effectLst/>
-        </p:spPr>
-        <p:style>
-          <a:lnRef idx="1">
-            <a:schemeClr val="accent1"/>
-          </a:lnRef>
-          <a:fillRef idx="3">
-            <a:schemeClr val="accent1"/>
-          </a:fillRef>
-          <a:effectRef idx="2">
-            <a:schemeClr val="accent1"/>
-          </a:effectRef>
-          <a:fontRef idx="minor">
-            <a:schemeClr val="lt1"/>
-          </a:fontRef>
-        </p:style>
-        <p:txBody>
-          <a:bodyPr rtlCol="0" anchor="ctr"/>
-          <a:lstStyle/>
-          <a:p>
-            <a:pPr algn="ctr"/>
-          </a:p>
-        </p:txBody>
-      </p:sp>
-      <p:sp>
-        <p:nvSpPr>
-          <p:cNvPr id="7" name="TextBox 6"/>
+          <p:cNvPr id="6" name="TextBox 5"/>
           <p:cNvSpPr txBox="1"/>
           <p:nvPr/>
         </p:nvSpPr>
         <p:spPr>
           <a:xfrm>
-            <a:off x="8814816" y="1828800"/>
-            <a:ext cx="2578608" cy="777240"/>
+            <a:off x="640080" y="6291072"/>
+            <a:ext cx="10972800" cy="274320"/>
           </a:xfrm>
           <a:prstGeom prst="rect">
             <a:avLst/>
@@ -10217,375 +11451,17 @@
           <a:p>
             <a:pPr algn="l">
               <a:spcAft>
-                <a:spcPts val="200"/>
-              </a:spcAft>
-            </a:pPr>
-            <a:r>
-              <a:rPr sz="2000" b="1">
-                <a:solidFill>
-                  <a:srgbClr val="1B5FAF"/>
-                </a:solidFill>
-                <a:latin typeface="Segoe UI"/>
-              </a:rPr>
-              <a:t>23</a:t>
-            </a:r>
-          </a:p>
-          <a:p>
-            <a:pPr>
-              <a:spcAft>
                 <a:spcPts val="0"/>
               </a:spcAft>
             </a:pPr>
             <a:r>
-              <a:rPr sz="1050" b="0">
+              <a:rPr sz="950" b="0">
                 <a:solidFill>
                   <a:srgbClr val="5A6474"/>
                 </a:solidFill>
                 <a:latin typeface="Segoe UI"/>
               </a:rPr>
-              <a:t>zones flagged, all peripheral</a:t>
-            </a:r>
-          </a:p>
-        </p:txBody>
-      </p:sp>
-      <p:sp>
-        <p:nvSpPr>
-          <p:cNvPr id="8" name="Rectangle 7"/>
-          <p:cNvSpPr/>
-          <p:nvPr/>
-        </p:nvSpPr>
-        <p:spPr>
-          <a:xfrm>
-            <a:off x="8686800" y="2834640"/>
-            <a:ext cx="2834640" cy="960120"/>
-          </a:xfrm>
-          <a:prstGeom prst="rect">
-            <a:avLst/>
-          </a:prstGeom>
-          <a:solidFill>
-            <a:srgbClr val="F1F5FA"/>
-          </a:solidFill>
-          <a:ln w="9525">
-            <a:solidFill>
-              <a:srgbClr val="C3CEDC"/>
-            </a:solidFill>
-          </a:ln>
-          <a:effectLst/>
-        </p:spPr>
-        <p:style>
-          <a:lnRef idx="1">
-            <a:schemeClr val="accent1"/>
-          </a:lnRef>
-          <a:fillRef idx="3">
-            <a:schemeClr val="accent1"/>
-          </a:fillRef>
-          <a:effectRef idx="2">
-            <a:schemeClr val="accent1"/>
-          </a:effectRef>
-          <a:fontRef idx="minor">
-            <a:schemeClr val="lt1"/>
-          </a:fontRef>
-        </p:style>
-        <p:txBody>
-          <a:bodyPr rtlCol="0" anchor="ctr"/>
-          <a:lstStyle/>
-          <a:p>
-            <a:pPr algn="ctr"/>
-          </a:p>
-        </p:txBody>
-      </p:sp>
-      <p:sp>
-        <p:nvSpPr>
-          <p:cNvPr id="9" name="TextBox 8"/>
-          <p:cNvSpPr txBox="1"/>
-          <p:nvPr/>
-        </p:nvSpPr>
-        <p:spPr>
-          <a:xfrm>
-            <a:off x="8814816" y="2926080"/>
-            <a:ext cx="2578608" cy="777240"/>
-          </a:xfrm>
-          <a:prstGeom prst="rect">
-            <a:avLst/>
-          </a:prstGeom>
-          <a:noFill/>
-        </p:spPr>
-        <p:txBody>
-          <a:bodyPr wrap="square">
-            <a:spAutoFit/>
-          </a:bodyPr>
-          <a:lstStyle/>
-          <a:p>
-            <a:pPr algn="l">
-              <a:spcAft>
-                <a:spcPts val="200"/>
-              </a:spcAft>
-            </a:pPr>
-            <a:r>
-              <a:rPr sz="2000" b="1">
-                <a:solidFill>
-                  <a:srgbClr val="0E7A52"/>
-                </a:solidFill>
-                <a:latin typeface="Segoe UI"/>
-              </a:rPr>
-              <a:t>82 %</a:t>
-            </a:r>
-          </a:p>
-          <a:p>
-            <a:pPr>
-              <a:spcAft>
-                <a:spcPts val="0"/>
-              </a:spcAft>
-            </a:pPr>
-            <a:r>
-              <a:rPr sz="1050" b="0">
-                <a:solidFill>
-                  <a:srgbClr val="5A6474"/>
-                </a:solidFill>
-                <a:latin typeface="Segoe UI"/>
-              </a:rPr>
-              <a:t>of ghost cells contain buildings in 2023 (Open Buildings)</a:t>
-            </a:r>
-          </a:p>
-        </p:txBody>
-      </p:sp>
-      <p:sp>
-        <p:nvSpPr>
-          <p:cNvPr id="10" name="Rectangle 9"/>
-          <p:cNvSpPr/>
-          <p:nvPr/>
-        </p:nvSpPr>
-        <p:spPr>
-          <a:xfrm>
-            <a:off x="8686800" y="3931920"/>
-            <a:ext cx="2834640" cy="960120"/>
-          </a:xfrm>
-          <a:prstGeom prst="rect">
-            <a:avLst/>
-          </a:prstGeom>
-          <a:solidFill>
-            <a:srgbClr val="F1F5FA"/>
-          </a:solidFill>
-          <a:ln w="9525">
-            <a:solidFill>
-              <a:srgbClr val="C3CEDC"/>
-            </a:solidFill>
-          </a:ln>
-          <a:effectLst/>
-        </p:spPr>
-        <p:style>
-          <a:lnRef idx="1">
-            <a:schemeClr val="accent1"/>
-          </a:lnRef>
-          <a:fillRef idx="3">
-            <a:schemeClr val="accent1"/>
-          </a:fillRef>
-          <a:effectRef idx="2">
-            <a:schemeClr val="accent1"/>
-          </a:effectRef>
-          <a:fontRef idx="minor">
-            <a:schemeClr val="lt1"/>
-          </a:fontRef>
-        </p:style>
-        <p:txBody>
-          <a:bodyPr rtlCol="0" anchor="ctr"/>
-          <a:lstStyle/>
-          <a:p>
-            <a:pPr algn="ctr"/>
-          </a:p>
-        </p:txBody>
-      </p:sp>
-      <p:sp>
-        <p:nvSpPr>
-          <p:cNvPr id="11" name="TextBox 10"/>
-          <p:cNvSpPr txBox="1"/>
-          <p:nvPr/>
-        </p:nvSpPr>
-        <p:spPr>
-          <a:xfrm>
-            <a:off x="8814816" y="4023360"/>
-            <a:ext cx="2578608" cy="777240"/>
-          </a:xfrm>
-          <a:prstGeom prst="rect">
-            <a:avLst/>
-          </a:prstGeom>
-          <a:noFill/>
-        </p:spPr>
-        <p:txBody>
-          <a:bodyPr wrap="square">
-            <a:spAutoFit/>
-          </a:bodyPr>
-          <a:lstStyle/>
-          <a:p>
-            <a:pPr algn="l">
-              <a:spcAft>
-                <a:spcPts val="200"/>
-              </a:spcAft>
-            </a:pPr>
-            <a:r>
-              <a:rPr sz="2000" b="1">
-                <a:solidFill>
-                  <a:srgbClr val="B26A00"/>
-                </a:solidFill>
-                <a:latin typeface="Segoe UI"/>
-              </a:rPr>
-              <a:t>26 of 144</a:t>
-            </a:r>
-          </a:p>
-          <a:p>
-            <a:pPr>
-              <a:spcAft>
-                <a:spcPts val="0"/>
-              </a:spcAft>
-            </a:pPr>
-            <a:r>
-              <a:rPr sz="1050" b="0">
-                <a:solidFill>
-                  <a:srgbClr val="5A6474"/>
-                </a:solidFill>
-                <a:latin typeface="Segoe UI"/>
-              </a:rPr>
-              <a:t>ghost cells have no buildings - likely GHSL false positives</a:t>
-            </a:r>
-          </a:p>
-        </p:txBody>
-      </p:sp>
-      <p:sp>
-        <p:nvSpPr>
-          <p:cNvPr id="12" name="Rectangle 11"/>
-          <p:cNvSpPr/>
-          <p:nvPr/>
-        </p:nvSpPr>
-        <p:spPr>
-          <a:xfrm>
-            <a:off x="8686800" y="5029200"/>
-            <a:ext cx="2834640" cy="960120"/>
-          </a:xfrm>
-          <a:prstGeom prst="rect">
-            <a:avLst/>
-          </a:prstGeom>
-          <a:solidFill>
-            <a:srgbClr val="F1F5FA"/>
-          </a:solidFill>
-          <a:ln w="9525">
-            <a:solidFill>
-              <a:srgbClr val="C3CEDC"/>
-            </a:solidFill>
-          </a:ln>
-          <a:effectLst/>
-        </p:spPr>
-        <p:style>
-          <a:lnRef idx="1">
-            <a:schemeClr val="accent1"/>
-          </a:lnRef>
-          <a:fillRef idx="3">
-            <a:schemeClr val="accent1"/>
-          </a:fillRef>
-          <a:effectRef idx="2">
-            <a:schemeClr val="accent1"/>
-          </a:effectRef>
-          <a:fontRef idx="minor">
-            <a:schemeClr val="lt1"/>
-          </a:fontRef>
-        </p:style>
-        <p:txBody>
-          <a:bodyPr rtlCol="0" anchor="ctr"/>
-          <a:lstStyle/>
-          <a:p>
-            <a:pPr algn="ctr"/>
-          </a:p>
-        </p:txBody>
-      </p:sp>
-      <p:sp>
-        <p:nvSpPr>
-          <p:cNvPr id="13" name="TextBox 12"/>
-          <p:cNvSpPr txBox="1"/>
-          <p:nvPr/>
-        </p:nvSpPr>
-        <p:spPr>
-          <a:xfrm>
-            <a:off x="8814816" y="5120640"/>
-            <a:ext cx="2578608" cy="777240"/>
-          </a:xfrm>
-          <a:prstGeom prst="rect">
-            <a:avLst/>
-          </a:prstGeom>
-          <a:noFill/>
-        </p:spPr>
-        <p:txBody>
-          <a:bodyPr wrap="square">
-            <a:spAutoFit/>
-          </a:bodyPr>
-          <a:lstStyle/>
-          <a:p>
-            <a:pPr algn="l">
-              <a:spcAft>
-                <a:spcPts val="200"/>
-              </a:spcAft>
-            </a:pPr>
-            <a:r>
-              <a:rPr sz="2000" b="1">
-                <a:solidFill>
-                  <a:srgbClr val="1B5FAF"/>
-                </a:solidFill>
-                <a:latin typeface="Segoe UI"/>
-              </a:rPr>
-              <a:t>+0.32 m</a:t>
-            </a:r>
-          </a:p>
-          <a:p>
-            <a:pPr>
-              <a:spcAft>
-                <a:spcPts val="0"/>
-              </a:spcAft>
-            </a:pPr>
-            <a:r>
-              <a:rPr sz="1050" b="0">
-                <a:solidFill>
-                  <a:srgbClr val="5A6474"/>
-                </a:solidFill>
-                <a:latin typeface="Segoe UI"/>
-              </a:rPr>
-              <a:t>building height gained 2016-2023 in ghost cells</a:t>
-            </a:r>
-          </a:p>
-        </p:txBody>
-      </p:sp>
-      <p:sp>
-        <p:nvSpPr>
-          <p:cNvPr id="14" name="TextBox 13"/>
-          <p:cNvSpPr txBox="1"/>
-          <p:nvPr/>
-        </p:nvSpPr>
-        <p:spPr>
-          <a:xfrm>
-            <a:off x="640080" y="6291072"/>
-            <a:ext cx="10972800" cy="274320"/>
-          </a:xfrm>
-          <a:prstGeom prst="rect">
-            <a:avLst/>
-          </a:prstGeom>
-          <a:noFill/>
-        </p:spPr>
-        <p:txBody>
-          <a:bodyPr wrap="square">
-            <a:spAutoFit/>
-          </a:bodyPr>
-          <a:lstStyle/>
-          <a:p>
-            <a:pPr algn="l">
-              <a:spcAft>
-                <a:spcPts val="0"/>
-              </a:spcAft>
-            </a:pPr>
-            <a:r>
-              <a:rPr sz="950" b="0">
-                <a:solidFill>
-                  <a:srgbClr val="5A6474"/>
-                </a:solidFill>
-                <a:latin typeface="Segoe UI"/>
-              </a:rPr>
-              <a:t>Evidence for a reader, not a validation: precision stays unmeasured until ground or image labels exist - Review 4.</a:t>
+              <a:t>Why the light trend is relative to the city: docs/diagrams/A4_relative_light_trend.png.</a:t>
             </a:r>
           </a:p>
         </p:txBody>
@@ -10686,7 +11562,7 @@
                 </a:solidFill>
                 <a:latin typeface="Segoe UI"/>
               </a:rPr>
-              <a:t>Surface heat: the result reversed</a:t>
+              <a:t>Ghost growth: is the split real?</a:t>
             </a:r>
           </a:p>
           <a:p>
@@ -10702,7 +11578,7 @@
                 </a:solidFill>
                 <a:latin typeface="Segoe UI"/>
               </a:rPr>
-              <a:t>March to May, daytime</a:t>
+              <a:t>The rule decides how the same 5.56 km2 of candidates divides</a:t>
             </a:r>
           </a:p>
         </p:txBody>
@@ -10753,7 +11629,7 @@
       </p:sp>
       <p:pic>
         <p:nvPicPr>
-          <p:cNvPr id="5" name="Picture 4" descr="F12_land_surface_temperature.png"/>
+          <p:cNvPr id="5" name="Picture 4" descr="F04_rule_sensitivity.png"/>
           <p:cNvPicPr>
             <a:picLocks noChangeAspect="1"/>
           </p:cNvPicPr>
@@ -10768,23 +11644,47 @@
         <p:spPr>
           <a:xfrm>
             <a:off x="640080" y="1600200"/>
-            <a:ext cx="10881360" cy="3570256"/>
+            <a:ext cx="5486400" cy="3082606"/>
           </a:xfrm>
           <a:prstGeom prst="rect">
             <a:avLst/>
           </a:prstGeom>
         </p:spPr>
       </p:pic>
-      <p:sp>
-        <p:nvSpPr>
-          <p:cNvPr id="6" name="Rectangle 5"/>
+      <p:pic>
+        <p:nvPicPr>
+          <p:cNvPr id="6" name="Picture 5" descr="F05_holdout.png"/>
+          <p:cNvPicPr>
+            <a:picLocks noChangeAspect="1"/>
+          </p:cNvPicPr>
+          <p:nvPr/>
+        </p:nvPicPr>
+        <p:blipFill>
+          <a:blip r:embed="rId3"/>
+          <a:stretch>
+            <a:fillRect/>
+          </a:stretch>
+        </p:blipFill>
+        <p:spPr>
+          <a:xfrm>
+            <a:off x="6309360" y="1600200"/>
+            <a:ext cx="5486400" cy="2792555"/>
+          </a:xfrm>
+          <a:prstGeom prst="rect">
+            <a:avLst/>
+          </a:prstGeom>
+        </p:spPr>
+      </p:pic>
+      <p:sp>
+        <p:nvSpPr>
+          <p:cNvPr id="7" name="Rectangle 6"/>
           <p:cNvSpPr/>
           <p:nvPr/>
         </p:nvSpPr>
         <p:spPr>
           <a:xfrm>
-            <a:off x="640080" y="4709160"/>
-            <a:ext cx="10881360" cy="1463040"/>
+            <a:off x="640080" y="4846320"/>
+            <a:ext cx="10881360" cy="1371600"/>
           </a:xfrm>
           <a:prstGeom prst="rect">
             <a:avLst/>
@@ -10794,7 +11694,7 @@
           </a:solidFill>
           <a:ln w="9525">
             <a:solidFill>
-              <a:srgbClr val="B26A00"/>
+              <a:srgbClr val="D5DDE8"/>
             </a:solidFill>
           </a:ln>
           <a:effectLst/>
@@ -10823,14 +11723,14 @@
       </p:sp>
       <p:sp>
         <p:nvSpPr>
-          <p:cNvPr id="7" name="TextBox 6"/>
+          <p:cNvPr id="8" name="TextBox 7"/>
           <p:cNvSpPr txBox="1"/>
           <p:nvPr/>
         </p:nvSpPr>
         <p:spPr>
           <a:xfrm>
-            <a:off x="868680" y="4846320"/>
-            <a:ext cx="10424160" cy="1234440"/>
+            <a:off x="868680" y="4983480"/>
+            <a:ext cx="10424160" cy="1143000"/>
           </a:xfrm>
           <a:prstGeom prst="rect">
             <a:avLst/>
@@ -10849,13 +11749,13 @@
               </a:spcAft>
             </a:pPr>
             <a:r>
-              <a:rPr sz="1500" b="1">
-                <a:solidFill>
-                  <a:srgbClr val="B26A00"/>
-                </a:solidFill>
-                <a:latin typeface="Segoe UI"/>
-              </a:rPr>
-              <a:t>Varanasi has no daytime surface heat island in the pre-monsoon season.</a:t>
+              <a:rPr sz="1400" b="1">
+                <a:solidFill>
+                  <a:srgbClr val="101826"/>
+                </a:solidFill>
+                <a:latin typeface="Segoe UI"/>
+              </a:rPr>
+              <a:t>Hold-out test: classify with the 2013-2020 night lights only, then check what happened next.</a:t>
             </a:r>
           </a:p>
           <a:p>
@@ -10871,7 +11771,7 @@
                 </a:solidFill>
                 <a:latin typeface="Segoe UI"/>
               </a:rPr>
-              <a:t>Measured over urban cells, the built-up area is 1.66 C cooler than the dry, bare farmland around it, and MODIS - an independent sensor - shows no heat island either. 22.3 of the 23.8 km2 of hotspots lie on rural land. Review 2's +1.10 C was the mean over only the cells warmer than rural, which is positive by construction. Heat vulnerability, which weights heat by residents, remains the planning layer.</a:t>
+              <a:t>Cells called emerging went on to brighten, relative to the city, more than cells called ghost growth: p = 0.010 over 100 m cells and p = 0.031 over 500 m blocks. The split carries real information - and the effect is modest: an emerging cell out-brightened a ghost cell 56% of the time. It is a screening map, not a verdict.</a:t>
             </a:r>
           </a:p>
         </p:txBody>

</xml_diff>

<commit_message>
feat(deck): panel deck script; bullets() no longer overwrites a card heading
The heading fix also repairs two cards in Review3_Presentation.pptx.
</commit_message>
<xml_diff>
--- a/docs/Review3_Presentation.pptx
+++ b/docs/Review3_Presentation.pptx
@@ -5520,7 +5520,7 @@
         <p:spPr>
           <a:xfrm>
             <a:off x="640080" y="1572768"/>
-            <a:ext cx="5394960" cy="2127764"/>
+            <a:ext cx="5394960" cy="2126788"/>
           </a:xfrm>
           <a:prstGeom prst="rect">
             <a:avLst/>
@@ -5621,6 +5621,22 @@
           <a:p>
             <a:pPr algn="l">
               <a:spcAft>
+                <a:spcPts val="400"/>
+              </a:spcAft>
+            </a:pPr>
+            <a:r>
+              <a:rPr sz="1400" b="1">
+                <a:solidFill>
+                  <a:srgbClr val="1B5FAF"/>
+                </a:solidFill>
+                <a:latin typeface="Segoe UI"/>
+              </a:rPr>
+              <a:t>Population</a:t>
+            </a:r>
+          </a:p>
+          <a:p>
+            <a:pPr>
+              <a:spcAft>
                 <a:spcPts val="500"/>
               </a:spcAft>
             </a:pPr>
@@ -5737,6 +5753,22 @@
           <a:lstStyle/>
           <a:p>
             <a:pPr algn="l">
+              <a:spcAft>
+                <a:spcPts val="400"/>
+              </a:spcAft>
+            </a:pPr>
+            <a:r>
+              <a:rPr sz="1400" b="1">
+                <a:solidFill>
+                  <a:srgbClr val="0E7A52"/>
+                </a:solidFill>
+                <a:latin typeface="Segoe UI"/>
+              </a:rPr>
+              <a:t>Night light as an activity proxy</a:t>
+            </a:r>
+          </a:p>
+          <a:p>
+            <a:pPr>
               <a:spcAft>
                 <a:spcPts val="500"/>
               </a:spcAft>
@@ -6016,6 +6048,22 @@
           <a:p>
             <a:pPr algn="l">
               <a:spcAft>
+                <a:spcPts val="800"/>
+              </a:spcAft>
+            </a:pPr>
+            <a:r>
+              <a:rPr sz="1500" b="1">
+                <a:solidFill>
+                  <a:srgbClr val="B26A00"/>
+                </a:solidFill>
+                <a:latin typeface="Segoe UI"/>
+              </a:rPr>
+              <a:t>What we cannot claim yet</a:t>
+            </a:r>
+          </a:p>
+          <a:p>
+            <a:pPr>
+              <a:spcAft>
                 <a:spcPts val="700"/>
               </a:spcAft>
             </a:pPr>
@@ -6193,6 +6241,13 @@
               </a:rPr>
               <a:t>Review 4</a:t>
             </a:r>
+          </a:p>
+          <a:p>
+            <a:pPr>
+              <a:spcAft>
+                <a:spcPts val="800"/>
+              </a:spcAft>
+            </a:pPr>
             <a:r>
               <a:rPr sz="1150" b="1">
                 <a:solidFill>
@@ -9227,18 +9282,25 @@
           <a:p>
             <a:pPr algn="l">
               <a:spcAft>
+                <a:spcPts val="800"/>
+              </a:spcAft>
+            </a:pPr>
+            <a:r>
+              <a:rPr sz="1500" b="1">
+                <a:solidFill>
+                  <a:srgbClr val="1B5FAF"/>
+                </a:solidFill>
+                <a:latin typeface="Segoe UI"/>
+              </a:rPr>
+              <a:t>Satellite and gridded</a:t>
+            </a:r>
+          </a:p>
+          <a:p>
+            <a:pPr>
+              <a:spcAft>
                 <a:spcPts val="500"/>
               </a:spcAft>
             </a:pPr>
-            <a:r>
-              <a:rPr sz="1500" b="1">
-                <a:solidFill>
-                  <a:srgbClr val="1B5FAF"/>
-                </a:solidFill>
-                <a:latin typeface="Segoe UI"/>
-              </a:rPr>
-              <a:t>Satellite and gridded</a:t>
-            </a:r>
             <a:r>
               <a:rPr sz="1150" b="1">
                 <a:solidFill>
@@ -9555,18 +9617,25 @@
           <a:p>
             <a:pPr algn="l">
               <a:spcAft>
+                <a:spcPts val="800"/>
+              </a:spcAft>
+            </a:pPr>
+            <a:r>
+              <a:rPr sz="1500" b="1">
+                <a:solidFill>
+                  <a:srgbClr val="0E7A52"/>
+                </a:solidFill>
+                <a:latin typeface="Segoe UI"/>
+              </a:rPr>
+              <a:t>Indian records  (new)</a:t>
+            </a:r>
+          </a:p>
+          <a:p>
+            <a:pPr>
+              <a:spcAft>
                 <a:spcPts val="1000"/>
               </a:spcAft>
             </a:pPr>
-            <a:r>
-              <a:rPr sz="1500" b="1">
-                <a:solidFill>
-                  <a:srgbClr val="0E7A52"/>
-                </a:solidFill>
-                <a:latin typeface="Segoe UI"/>
-              </a:rPr>
-              <a:t>Indian records  (new)</a:t>
-            </a:r>
             <a:r>
               <a:rPr sz="1150" b="1">
                 <a:solidFill>

</xml_diff>